<commit_message>
Update presentation and user guide for Product 1 sub-modules
- PPTX: 20 slides (was 16), added Sales & Collections, Credit Rating,
  Accounting, Communications slides with screenshots
- Updated AI Chat slide (18 tools), Technical Summary, Next Steps
- Contact slide: added Simon Williams, Managing Partner
- Markdown presentation updated to match
- User guide: 4 new sections for the P1 sub-modules

Co-Authored-By: Claude Opus 4.6 (1M context) <noreply@anthropic.com>
</commit_message>
<xml_diff>
--- a/docs/AHMF_Platform_Overview.pptx
+++ b/docs/AHMF_Platform_Overview.pptx
@@ -21,6 +21,10 @@
     <p:sldId id="269" r:id="rId20"/>
     <p:sldId id="270" r:id="rId21"/>
     <p:sldId id="271" r:id="rId22"/>
+    <p:sldId id="272" r:id="rId23"/>
+    <p:sldId id="273" r:id="rId24"/>
+    <p:sldId id="274" r:id="rId25"/>
+    <p:sldId id="275" r:id="rId26"/>
   </p:sldIdLst>
   <p:sldSz cx="12191695" cy="6858000" type="screen4x3"/>
   <p:notesSz cx="6858000" cy="9144000"/>
@@ -3287,7 +3291,7 @@
               </a:defRPr>
             </a:pPr>
             <a:r>
-              <a:t>Deal Closing &amp; Data Room</a:t>
+              <a:t>Production Risk Scoring</a:t>
             </a:r>
           </a:p>
         </p:txBody>
@@ -3325,7 +3329,7 @@
               </a:defRPr>
             </a:pPr>
             <a:r>
-              <a:t>Infrastructure layer for streamlined closings</a:t>
+              <a:t>"Moody's for execution risk"</a:t>
             </a:r>
           </a:p>
           <a:p>
@@ -3347,158 +3351,131 @@
               </a:defRPr>
             </a:pPr>
             <a:r>
-              <a:t>Auto-generated 20-item closing checklists</a:t>
-            </a:r>
-          </a:p>
-          <a:p>
-            <a:pPr>
-              <a:spcBef>
-                <a:spcPts val="400"/>
-              </a:spcBef>
-              <a:defRPr sz="1400">
-                <a:solidFill>
-                  <a:srgbClr val="64748B"/>
-                </a:solidFill>
-              </a:defRPr>
-            </a:pPr>
-          </a:p>
-          <a:p>
-            <a:pPr>
-              <a:spcBef>
-                <a:spcPts val="1200"/>
-              </a:spcBef>
-              <a:defRPr sz="1600" b="1">
-                <a:solidFill>
-                  <a:srgbClr val="1E293B"/>
-                </a:solidFill>
-              </a:defRPr>
-            </a:pPr>
-            <a:r>
-              <a:t>6 Categories:</a:t>
-            </a:r>
-          </a:p>
-          <a:p>
-            <a:pPr>
-              <a:spcBef>
-                <a:spcPts val="400"/>
-              </a:spcBef>
-              <a:defRPr sz="1400">
-                <a:solidFill>
-                  <a:srgbClr val="64748B"/>
-                </a:solidFill>
-              </a:defRPr>
-            </a:pPr>
-            <a:r>
-              <a:t>  Legal (5 items) — loan agreements, security, completion guarantee</a:t>
-            </a:r>
-          </a:p>
-          <a:p>
-            <a:pPr>
-              <a:spcBef>
-                <a:spcPts val="400"/>
-              </a:spcBef>
-              <a:defRPr sz="1400">
-                <a:solidFill>
-                  <a:srgbClr val="64748B"/>
-                </a:solidFill>
-              </a:defRPr>
-            </a:pPr>
-            <a:r>
-              <a:t>  Insurance (3 items) — E&amp;O, production insurance, completion bond</a:t>
-            </a:r>
-          </a:p>
-          <a:p>
-            <a:pPr>
-              <a:spcBef>
-                <a:spcPts val="400"/>
-              </a:spcBef>
-              <a:defRPr sz="1400">
-                <a:solidFill>
-                  <a:srgbClr val="64748B"/>
-                </a:solidFill>
-              </a:defRPr>
-            </a:pPr>
-            <a:r>
-              <a:t>  Financial (4 items) — chain of title, budget, lab access, CAMA</a:t>
-            </a:r>
-          </a:p>
-          <a:p>
-            <a:pPr>
-              <a:spcBef>
-                <a:spcPts val="400"/>
-              </a:spcBef>
-              <a:defRPr sz="1400">
-                <a:solidFill>
-                  <a:srgbClr val="64748B"/>
-                </a:solidFill>
-              </a:defRPr>
-            </a:pPr>
-            <a:r>
-              <a:t>  Distribution (3 items) — agreements, delivery schedule, MG commitments</a:t>
-            </a:r>
-          </a:p>
-          <a:p>
-            <a:pPr>
-              <a:spcBef>
-                <a:spcPts val="400"/>
-              </a:spcBef>
-              <a:defRPr sz="1400">
-                <a:solidFill>
-                  <a:srgbClr val="64748B"/>
-                </a:solidFill>
-              </a:defRPr>
-            </a:pPr>
-            <a:r>
-              <a:t>  Tax Incentives (2 items) — applications, auditor opinion</a:t>
-            </a:r>
-          </a:p>
-          <a:p>
-            <a:pPr>
-              <a:spcBef>
-                <a:spcPts val="400"/>
-              </a:spcBef>
-              <a:defRPr sz="1400">
-                <a:solidFill>
-                  <a:srgbClr val="64748B"/>
-                </a:solidFill>
-              </a:defRPr>
-            </a:pPr>
-            <a:r>
-              <a:t>  Compliance (3 items) — KYC/AML, OFAC, board approval</a:t>
-            </a:r>
-          </a:p>
-          <a:p>
-            <a:pPr>
-              <a:spcBef>
-                <a:spcPts val="400"/>
-              </a:spcBef>
-              <a:defRPr sz="1400">
-                <a:solidFill>
-                  <a:srgbClr val="64748B"/>
-                </a:solidFill>
-              </a:defRPr>
-            </a:pPr>
-          </a:p>
-          <a:p>
-            <a:pPr>
-              <a:spcBef>
-                <a:spcPts val="400"/>
-              </a:spcBef>
-              <a:defRPr sz="1400">
-                <a:solidFill>
-                  <a:srgbClr val="64748B"/>
-                </a:solidFill>
-              </a:defRPr>
-            </a:pPr>
-            <a:r>
-              <a:t>Interactive checkbox tracking with progress bars</a:t>
+              <a:t>AI evaluates 6 risk dimensions on a 0-100 scale:</a:t>
+            </a:r>
+          </a:p>
+          <a:p>
+            <a:pPr>
+              <a:spcBef>
+                <a:spcPts val="400"/>
+              </a:spcBef>
+              <a:defRPr sz="1400">
+                <a:solidFill>
+                  <a:srgbClr val="64748B"/>
+                </a:solidFill>
+              </a:defRPr>
+            </a:pPr>
+            <a:r>
+              <a:t>  Script Complexity — locations, stunts, VFX density</a:t>
+            </a:r>
+          </a:p>
+          <a:p>
+            <a:pPr>
+              <a:spcBef>
+                <a:spcPts val="400"/>
+              </a:spcBef>
+              <a:defRPr sz="1400">
+                <a:solidFill>
+                  <a:srgbClr val="64748B"/>
+                </a:solidFill>
+              </a:defRPr>
+            </a:pPr>
+            <a:r>
+              <a:t>  Budget Feasibility — budget vs comparable films</a:t>
+            </a:r>
+          </a:p>
+          <a:p>
+            <a:pPr>
+              <a:spcBef>
+                <a:spcPts val="400"/>
+              </a:spcBef>
+              <a:defRPr sz="1400">
+                <a:solidFill>
+                  <a:srgbClr val="64748B"/>
+                </a:solidFill>
+              </a:defRPr>
+            </a:pPr>
+            <a:r>
+              <a:t>  Schedule Risk — shoot days vs scope</a:t>
+            </a:r>
+          </a:p>
+          <a:p>
+            <a:pPr>
+              <a:spcBef>
+                <a:spcPts val="400"/>
+              </a:spcBef>
+              <a:defRPr sz="1400">
+                <a:solidFill>
+                  <a:srgbClr val="64748B"/>
+                </a:solidFill>
+              </a:defRPr>
+            </a:pPr>
+            <a:r>
+              <a:t>  Jurisdictional Risk — labor laws, permits, stability</a:t>
+            </a:r>
+          </a:p>
+          <a:p>
+            <a:pPr>
+              <a:spcBef>
+                <a:spcPts val="400"/>
+              </a:spcBef>
+              <a:defRPr sz="1400">
+                <a:solidFill>
+                  <a:srgbClr val="64748B"/>
+                </a:solidFill>
+              </a:defRPr>
+            </a:pPr>
+            <a:r>
+              <a:t>  Crew/Talent Risk — availability, reliability, concentration</a:t>
+            </a:r>
+          </a:p>
+          <a:p>
+            <a:pPr>
+              <a:spcBef>
+                <a:spcPts val="400"/>
+              </a:spcBef>
+              <a:defRPr sz="1400">
+                <a:solidFill>
+                  <a:srgbClr val="64748B"/>
+                </a:solidFill>
+              </a:defRPr>
+            </a:pPr>
+            <a:r>
+              <a:t>  Completion Risk — on-time, on-budget probability</a:t>
+            </a:r>
+          </a:p>
+          <a:p>
+            <a:pPr>
+              <a:spcBef>
+                <a:spcPts val="400"/>
+              </a:spcBef>
+              <a:defRPr sz="1400">
+                <a:solidFill>
+                  <a:srgbClr val="64748B"/>
+                </a:solidFill>
+              </a:defRPr>
+            </a:pPr>
+          </a:p>
+          <a:p>
+            <a:pPr>
+              <a:spcBef>
+                <a:spcPts val="400"/>
+              </a:spcBef>
+              <a:defRPr sz="1400">
+                <a:solidFill>
+                  <a:srgbClr val="64748B"/>
+                </a:solidFill>
+              </a:defRPr>
+            </a:pPr>
+            <a:r>
+              <a:t>Output: Overall score, risk tier, mitigation recommendations</a:t>
             </a:r>
           </a:p>
         </p:txBody>
       </p:sp>
       <p:pic>
         <p:nvPicPr>
-          <p:cNvPr id="5" name="Picture 4" descr="13_checklist.png"/>
+          <p:cNvPr id="5" name="Picture 4" descr="08_risk_form.png"/>
           <p:cNvPicPr>
             <a:picLocks noChangeAspect="1"/>
           </p:cNvPicPr>
@@ -3646,7 +3623,7 @@
               </a:defRPr>
             </a:pPr>
             <a:r>
-              <a:t>Audience &amp; Marketing Intelligence</a:t>
+              <a:t>Smart Budgeting Tool</a:t>
             </a:r>
           </a:p>
         </p:txBody>
@@ -3684,7 +3661,7 @@
               </a:defRPr>
             </a:pPr>
             <a:r>
-              <a:t>Campaign simulator meets audience heat map</a:t>
+              <a:t>Generative budgeting logic + live cost intelligence</a:t>
             </a:r>
           </a:p>
           <a:p>
@@ -3706,104 +3683,146 @@
               </a:defRPr>
             </a:pPr>
             <a:r>
-              <a:t>AI-powered audience segmentation (3-5 segments)</a:t>
-            </a:r>
-          </a:p>
-          <a:p>
-            <a:pPr>
-              <a:spcBef>
-                <a:spcPts val="400"/>
-              </a:spcBef>
-              <a:defRPr sz="1400">
-                <a:solidFill>
-                  <a:srgbClr val="64748B"/>
-                </a:solidFill>
-              </a:defRPr>
-            </a:pPr>
-            <a:r>
-              <a:t>Demographic + psychographic clustering with % share</a:t>
-            </a:r>
-          </a:p>
-          <a:p>
-            <a:pPr>
-              <a:spcBef>
-                <a:spcPts val="400"/>
-              </a:spcBef>
-              <a:defRPr sz="1400">
-                <a:solidFill>
-                  <a:srgbClr val="64748B"/>
-                </a:solidFill>
-              </a:defRPr>
-            </a:pPr>
-            <a:r>
-              <a:t>Marketing channel allocation and spend estimates</a:t>
-            </a:r>
-          </a:p>
-          <a:p>
-            <a:pPr>
-              <a:spcBef>
-                <a:spcPts val="400"/>
-              </a:spcBef>
-              <a:defRPr sz="1400">
-                <a:solidFill>
-                  <a:srgbClr val="64748B"/>
-                </a:solidFill>
-              </a:defRPr>
-            </a:pPr>
-            <a:r>
-              <a:t>Release window optimization</a:t>
-            </a:r>
-          </a:p>
-          <a:p>
-            <a:pPr>
-              <a:spcBef>
-                <a:spcPts val="400"/>
-              </a:spcBef>
-              <a:defRPr sz="1400">
-                <a:solidFill>
-                  <a:srgbClr val="64748B"/>
-                </a:solidFill>
-              </a:defRPr>
-            </a:pPr>
-            <a:r>
-              <a:t>Platform strategy (theatrical, streaming, hybrid)</a:t>
-            </a:r>
-          </a:p>
-          <a:p>
-            <a:pPr>
-              <a:spcBef>
-                <a:spcPts val="400"/>
-              </a:spcBef>
-              <a:defRPr sz="1400">
-                <a:solidFill>
-                  <a:srgbClr val="64748B"/>
-                </a:solidFill>
-              </a:defRPr>
-            </a:pPr>
-            <a:r>
-              <a:t>Festival positioning recommendations</a:t>
-            </a:r>
-          </a:p>
-          <a:p>
-            <a:pPr>
-              <a:spcBef>
-                <a:spcPts val="400"/>
-              </a:spcBef>
-              <a:defRPr sz="1400">
-                <a:solidFill>
-                  <a:srgbClr val="64748B"/>
-                </a:solidFill>
-              </a:defRPr>
-            </a:pPr>
-            <a:r>
-              <a:t>Comparable film marketing analysis</a:t>
+              <a:t>AI generates 3 scenarios: Low / Mid / High</a:t>
+            </a:r>
+          </a:p>
+          <a:p>
+            <a:pPr>
+              <a:spcBef>
+                <a:spcPts val="400"/>
+              </a:spcBef>
+              <a:defRPr sz="1400">
+                <a:solidFill>
+                  <a:srgbClr val="64748B"/>
+                </a:solidFill>
+              </a:defRPr>
+            </a:pPr>
+            <a:r>
+              <a:t>8-12 detailed line items per scenario</a:t>
+            </a:r>
+          </a:p>
+          <a:p>
+            <a:pPr>
+              <a:spcBef>
+                <a:spcPts val="400"/>
+              </a:spcBef>
+              <a:defRPr sz="1400">
+                <a:solidFill>
+                  <a:srgbClr val="64748B"/>
+                </a:solidFill>
+              </a:defRPr>
+            </a:pPr>
+          </a:p>
+          <a:p>
+            <a:pPr>
+              <a:spcBef>
+                <a:spcPts val="1200"/>
+              </a:spcBef>
+              <a:defRPr sz="1600" b="1">
+                <a:solidFill>
+                  <a:srgbClr val="1E293B"/>
+                </a:solidFill>
+              </a:defRPr>
+            </a:pPr>
+            <a:r>
+              <a:t>Budget Categories:</a:t>
+            </a:r>
+          </a:p>
+          <a:p>
+            <a:pPr>
+              <a:spcBef>
+                <a:spcPts val="400"/>
+              </a:spcBef>
+              <a:defRPr sz="1400">
+                <a:solidFill>
+                  <a:srgbClr val="64748B"/>
+                </a:solidFill>
+              </a:defRPr>
+            </a:pPr>
+            <a:r>
+              <a:t>Above-the-Line (talent, director, producer fees)</a:t>
+            </a:r>
+          </a:p>
+          <a:p>
+            <a:pPr>
+              <a:spcBef>
+                <a:spcPts val="400"/>
+              </a:spcBef>
+              <a:defRPr sz="1400">
+                <a:solidFill>
+                  <a:srgbClr val="64748B"/>
+                </a:solidFill>
+              </a:defRPr>
+            </a:pPr>
+            <a:r>
+              <a:t>Below-the-Line Production (crew, equipment, locations)</a:t>
+            </a:r>
+          </a:p>
+          <a:p>
+            <a:pPr>
+              <a:spcBef>
+                <a:spcPts val="400"/>
+              </a:spcBef>
+              <a:defRPr sz="1400">
+                <a:solidFill>
+                  <a:srgbClr val="64748B"/>
+                </a:solidFill>
+              </a:defRPr>
+            </a:pPr>
+            <a:r>
+              <a:t>Below-the-Line Post (editing, VFX, sound, music)</a:t>
+            </a:r>
+          </a:p>
+          <a:p>
+            <a:pPr>
+              <a:spcBef>
+                <a:spcPts val="400"/>
+              </a:spcBef>
+              <a:defRPr sz="1400">
+                <a:solidFill>
+                  <a:srgbClr val="64748B"/>
+                </a:solidFill>
+              </a:defRPr>
+            </a:pPr>
+            <a:r>
+              <a:t>Insurance &amp; Legal</a:t>
+            </a:r>
+          </a:p>
+          <a:p>
+            <a:pPr>
+              <a:spcBef>
+                <a:spcPts val="400"/>
+              </a:spcBef>
+              <a:defRPr sz="1400">
+                <a:solidFill>
+                  <a:srgbClr val="64748B"/>
+                </a:solidFill>
+              </a:defRPr>
+            </a:pPr>
+            <a:r>
+              <a:t>Financing Costs</a:t>
+            </a:r>
+          </a:p>
+          <a:p>
+            <a:pPr>
+              <a:spcBef>
+                <a:spcPts val="400"/>
+              </a:spcBef>
+              <a:defRPr sz="1400">
+                <a:solidFill>
+                  <a:srgbClr val="64748B"/>
+                </a:solidFill>
+              </a:defRPr>
+            </a:pPr>
+            <a:r>
+              <a:t>Contingency (typically 10%)</a:t>
             </a:r>
           </a:p>
         </p:txBody>
       </p:sp>
       <p:pic>
         <p:nvPicPr>
-          <p:cNvPr id="5" name="Picture 4" descr="11_audience.png"/>
+          <p:cNvPr id="5" name="Picture 4" descr="09_budget.png"/>
           <p:cNvPicPr>
             <a:picLocks noChangeAspect="1"/>
           </p:cNvPicPr>
@@ -3951,7 +3970,7 @@
               </a:defRPr>
             </a:pPr>
             <a:r>
-              <a:t>Talent Intelligence</a:t>
+              <a:t>Automated Production Scheduling</a:t>
             </a:r>
           </a:p>
         </p:txBody>
@@ -3989,7 +4008,7 @@
               </a:defRPr>
             </a:pPr>
             <a:r>
-              <a:t>Taste graph meets market intelligence</a:t>
+              <a:t>Predictive production efficiency software</a:t>
             </a:r>
           </a:p>
           <a:p>
@@ -4011,131 +4030,104 @@
               </a:defRPr>
             </a:pPr>
             <a:r>
-              <a:t>Live TMDB actor/director search with popularity data</a:t>
-            </a:r>
-          </a:p>
-          <a:p>
-            <a:pPr>
-              <a:spcBef>
-                <a:spcPts val="400"/>
-              </a:spcBef>
-              <a:defRPr sz="1400">
-                <a:solidFill>
-                  <a:srgbClr val="64748B"/>
-                </a:solidFill>
-              </a:defRPr>
-            </a:pPr>
-            <a:r>
-              <a:t>AI cast recommendations scored on:</a:t>
-            </a:r>
-          </a:p>
-          <a:p>
-            <a:pPr>
-              <a:spcBef>
-                <a:spcPts val="400"/>
-              </a:spcBef>
-              <a:defRPr sz="1400">
-                <a:solidFill>
-                  <a:srgbClr val="64748B"/>
-                </a:solidFill>
-              </a:defRPr>
-            </a:pPr>
-            <a:r>
-              <a:t>  Heat Index (1-10) — current market popularity</a:t>
-            </a:r>
-          </a:p>
-          <a:p>
-            <a:pPr>
-              <a:spcBef>
-                <a:spcPts val="400"/>
-              </a:spcBef>
-              <a:defRPr sz="1400">
-                <a:solidFill>
-                  <a:srgbClr val="64748B"/>
-                </a:solidFill>
-              </a:defRPr>
-            </a:pPr>
-            <a:r>
-              <a:t>  Genre Fit (1-10) — alignment with project tone</a:t>
-            </a:r>
-          </a:p>
-          <a:p>
-            <a:pPr>
-              <a:spcBef>
-                <a:spcPts val="400"/>
-              </a:spcBef>
-              <a:defRPr sz="1400">
-                <a:solidFill>
-                  <a:srgbClr val="64748B"/>
-                </a:solidFill>
-              </a:defRPr>
-            </a:pPr>
-            <a:r>
-              <a:t>  Salary Tier — Low / Mid / High / Premium</a:t>
-            </a:r>
-          </a:p>
-          <a:p>
-            <a:pPr>
-              <a:spcBef>
-                <a:spcPts val="400"/>
-              </a:spcBef>
-              <a:defRPr sz="1400">
-                <a:solidFill>
-                  <a:srgbClr val="64748B"/>
-                </a:solidFill>
-              </a:defRPr>
-            </a:pPr>
-            <a:r>
-              <a:t>  International Sales Impact — Low / Mid / High</a:t>
-            </a:r>
-          </a:p>
-          <a:p>
-            <a:pPr>
-              <a:spcBef>
-                <a:spcPts val="400"/>
-              </a:spcBef>
-              <a:defRPr sz="1400">
-                <a:solidFill>
-                  <a:srgbClr val="64748B"/>
-                </a:solidFill>
-              </a:defRPr>
-            </a:pPr>
-          </a:p>
-          <a:p>
-            <a:pPr>
-              <a:spcBef>
-                <a:spcPts val="400"/>
-              </a:spcBef>
-              <a:defRPr sz="1400">
-                <a:solidFill>
-                  <a:srgbClr val="64748B"/>
-                </a:solidFill>
-              </a:defRPr>
-            </a:pPr>
-            <a:r>
-              <a:t>Package simulation: test cast combinations for projected revenue</a:t>
-            </a:r>
-          </a:p>
-          <a:p>
-            <a:pPr>
-              <a:spcBef>
-                <a:spcPts val="400"/>
-              </a:spcBef>
-              <a:defRPr sz="1400">
-                <a:solidFill>
-                  <a:srgbClr val="64748B"/>
-                </a:solidFill>
-              </a:defRPr>
-            </a:pPr>
-            <a:r>
-              <a:t>Comparable role analysis from filmography data</a:t>
+              <a:t>AI generates day-by-day shooting schedules</a:t>
+            </a:r>
+          </a:p>
+          <a:p>
+            <a:pPr>
+              <a:spcBef>
+                <a:spcPts val="400"/>
+              </a:spcBef>
+              <a:defRPr sz="1400">
+                <a:solidFill>
+                  <a:srgbClr val="64748B"/>
+                </a:solidFill>
+              </a:defRPr>
+            </a:pPr>
+            <a:r>
+              <a:t>Location clustering optimization (minimize company moves)</a:t>
+            </a:r>
+          </a:p>
+          <a:p>
+            <a:pPr>
+              <a:spcBef>
+                <a:spcPts val="400"/>
+              </a:spcBef>
+              <a:defRPr sz="1400">
+                <a:solidFill>
+                  <a:srgbClr val="64748B"/>
+                </a:solidFill>
+              </a:defRPr>
+            </a:pPr>
+            <a:r>
+              <a:t>Day/night scene grouping</a:t>
+            </a:r>
+          </a:p>
+          <a:p>
+            <a:pPr>
+              <a:spcBef>
+                <a:spcPts val="400"/>
+              </a:spcBef>
+              <a:defRPr sz="1400">
+                <a:solidFill>
+                  <a:srgbClr val="64748B"/>
+                </a:solidFill>
+              </a:defRPr>
+            </a:pPr>
+            <a:r>
+              <a:t>Actor availability and labor law compliance</a:t>
+            </a:r>
+          </a:p>
+          <a:p>
+            <a:pPr>
+              <a:spcBef>
+                <a:spcPts val="400"/>
+              </a:spcBef>
+              <a:defRPr sz="1400">
+                <a:solidFill>
+                  <a:srgbClr val="64748B"/>
+                </a:solidFill>
+              </a:defRPr>
+            </a:pPr>
+            <a:r>
+              <a:t>Bottleneck prediction</a:t>
+            </a:r>
+          </a:p>
+          <a:p>
+            <a:pPr>
+              <a:spcBef>
+                <a:spcPts val="400"/>
+              </a:spcBef>
+              <a:defRPr sz="1400">
+                <a:solidFill>
+                  <a:srgbClr val="64748B"/>
+                </a:solidFill>
+              </a:defRPr>
+            </a:pPr>
+            <a:r>
+              <a:t>Scenario comparison (schedule A vs B)</a:t>
+            </a:r>
+          </a:p>
+          <a:p>
+            <a:pPr>
+              <a:spcBef>
+                <a:spcPts val="400"/>
+              </a:spcBef>
+              <a:defRPr sz="1400">
+                <a:solidFill>
+                  <a:srgbClr val="64748B"/>
+                </a:solidFill>
+              </a:defRPr>
+            </a:pPr>
+            <a:r>
+              <a:t>Integration with budgeting tool</a:t>
             </a:r>
           </a:p>
         </p:txBody>
       </p:sp>
       <p:pic>
         <p:nvPicPr>
-          <p:cNvPr id="5" name="Picture 4" descr="14_talent_search.png"/>
+          <p:cNvPr id="5" name="Picture 4" descr="10_schedule.png"/>
           <p:cNvPicPr>
             <a:picLocks noChangeAspect="1"/>
           </p:cNvPicPr>
@@ -4150,7 +4142,7 @@
         <p:spPr>
           <a:xfrm>
             <a:off x="6217920" y="1188720"/>
-            <a:ext cx="5303520" cy="5162989"/>
+            <a:ext cx="5303520" cy="3729038"/>
           </a:xfrm>
           <a:prstGeom prst="rect">
             <a:avLst/>
@@ -4283,7 +4275,7 @@
               </a:defRPr>
             </a:pPr>
             <a:r>
-              <a:t>AI Chat — The Intelligence Layer</a:t>
+              <a:t>Soft Funding Discovery Engine</a:t>
             </a:r>
           </a:p>
         </p:txBody>
@@ -4321,7 +4313,7 @@
               </a:defRPr>
             </a:pPr>
             <a:r>
-              <a:t>14 AI tools accessible via natural language or structured commands</a:t>
+              <a:t>"Kayak for film incentives"</a:t>
             </a:r>
           </a:p>
           <a:p>
@@ -4343,131 +4335,173 @@
               </a:defRPr>
             </a:pPr>
             <a:r>
-              <a:t>deal:list — View all deals in pipeline</a:t>
-            </a:r>
-          </a:p>
-          <a:p>
-            <a:pPr>
-              <a:spcBef>
-                <a:spcPts val="400"/>
-              </a:spcBef>
-              <a:defRPr sz="1400">
-                <a:solidFill>
-                  <a:srgbClr val="64748B"/>
-                </a:solidFill>
-              </a:defRPr>
-            </a:pPr>
-            <a:r>
-              <a:t>portfolio — Aggregate portfolio statistics</a:t>
-            </a:r>
-          </a:p>
-          <a:p>
-            <a:pPr>
-              <a:spcBef>
-                <a:spcPts val="400"/>
-              </a:spcBef>
-              <a:defRPr sz="1400">
-                <a:solidFill>
-                  <a:srgbClr val="64748B"/>
-                </a:solidFill>
-              </a:defRPr>
-            </a:pPr>
-            <a:r>
-              <a:t>contact:search NAME — Search contact database</a:t>
-            </a:r>
-          </a:p>
-          <a:p>
-            <a:pPr>
-              <a:spcBef>
-                <a:spcPts val="400"/>
-              </a:spcBef>
-              <a:defRPr sz="1400">
-                <a:solidFill>
-                  <a:srgbClr val="64748B"/>
-                </a:solidFill>
-              </a:defRPr>
-            </a:pPr>
-            <a:r>
-              <a:t>incentives — Search global film tax incentives</a:t>
-            </a:r>
-          </a:p>
-          <a:p>
-            <a:pPr>
-              <a:spcBef>
-                <a:spcPts val="400"/>
-              </a:spcBef>
-              <a:defRPr sz="1400">
-                <a:solidFill>
-                  <a:srgbClr val="64748B"/>
-                </a:solidFill>
-              </a:defRPr>
-            </a:pPr>
-            <a:r>
-              <a:t>talent:search NAME — Look up actors/directors via TMDB</a:t>
-            </a:r>
-          </a:p>
-          <a:p>
-            <a:pPr>
-              <a:spcBef>
-                <a:spcPts val="400"/>
-              </a:spcBef>
-              <a:defRPr sz="1400">
-                <a:solidFill>
-                  <a:srgbClr val="64748B"/>
-                </a:solidFill>
-              </a:defRPr>
-            </a:pPr>
-            <a:r>
-              <a:t>risk:new / budget:new / schedule:new — AI analysis tools</a:t>
-            </a:r>
-          </a:p>
-          <a:p>
-            <a:pPr>
-              <a:spcBef>
-                <a:spcPts val="400"/>
-              </a:spcBef>
-              <a:defRPr sz="1400">
-                <a:solidFill>
-                  <a:srgbClr val="64748B"/>
-                </a:solidFill>
-              </a:defRPr>
-            </a:pPr>
-            <a:r>
-              <a:t>audience:new — Audience &amp; marketing prediction</a:t>
-            </a:r>
-          </a:p>
-          <a:p>
-            <a:pPr>
-              <a:spcBef>
-                <a:spcPts val="400"/>
-              </a:spcBef>
-              <a:defRPr sz="1400">
-                <a:solidFill>
-                  <a:srgbClr val="64748B"/>
-                </a:solidFill>
-              </a:defRPr>
-            </a:pPr>
-          </a:p>
-          <a:p>
-            <a:pPr>
-              <a:spcBef>
-                <a:spcPts val="400"/>
-              </a:spcBef>
-              <a:defRPr sz="1400">
-                <a:solidFill>
-                  <a:srgbClr val="64748B"/>
-                </a:solidFill>
-              </a:defRPr>
-            </a:pPr>
-            <a:r>
-              <a:t>Or ask any question in natural language — AI routes to the right tool</a:t>
+              <a:t>Database of 16+ global incentive programs</a:t>
+            </a:r>
+          </a:p>
+          <a:p>
+            <a:pPr>
+              <a:spcBef>
+                <a:spcPts val="400"/>
+              </a:spcBef>
+              <a:defRPr sz="1400">
+                <a:solidFill>
+                  <a:srgbClr val="64748B"/>
+                </a:solidFill>
+              </a:defRPr>
+            </a:pPr>
+            <a:r>
+              <a:t>11 countries covered</a:t>
+            </a:r>
+          </a:p>
+          <a:p>
+            <a:pPr>
+              <a:spcBef>
+                <a:spcPts val="400"/>
+              </a:spcBef>
+              <a:defRPr sz="1400">
+                <a:solidFill>
+                  <a:srgbClr val="64748B"/>
+                </a:solidFill>
+              </a:defRPr>
+            </a:pPr>
+            <a:r>
+              <a:t>Average rebate: 27.8%</a:t>
+            </a:r>
+          </a:p>
+          <a:p>
+            <a:pPr>
+              <a:spcBef>
+                <a:spcPts val="400"/>
+              </a:spcBef>
+              <a:defRPr sz="1400">
+                <a:solidFill>
+                  <a:srgbClr val="64748B"/>
+                </a:solidFill>
+              </a:defRPr>
+            </a:pPr>
+          </a:p>
+          <a:p>
+            <a:pPr>
+              <a:spcBef>
+                <a:spcPts val="1200"/>
+              </a:spcBef>
+              <a:defRPr sz="1600" b="1">
+                <a:solidFill>
+                  <a:srgbClr val="1E293B"/>
+                </a:solidFill>
+              </a:defRPr>
+            </a:pPr>
+            <a:r>
+              <a:t>Top Programs:</a:t>
+            </a:r>
+          </a:p>
+          <a:p>
+            <a:pPr>
+              <a:spcBef>
+                <a:spcPts val="400"/>
+              </a:spcBef>
+              <a:defRPr sz="1400">
+                <a:solidFill>
+                  <a:srgbClr val="64748B"/>
+                </a:solidFill>
+              </a:defRPr>
+            </a:pPr>
+            <a:r>
+              <a:t>  Colombia Cash Rebate — 40%</a:t>
+            </a:r>
+          </a:p>
+          <a:p>
+            <a:pPr>
+              <a:spcBef>
+                <a:spcPts val="400"/>
+              </a:spcBef>
+              <a:defRPr sz="1400">
+                <a:solidFill>
+                  <a:srgbClr val="64748B"/>
+                </a:solidFill>
+              </a:defRPr>
+            </a:pPr>
+            <a:r>
+              <a:t>  Ireland Section 481 — 32%</a:t>
+            </a:r>
+          </a:p>
+          <a:p>
+            <a:pPr>
+              <a:spcBef>
+                <a:spcPts val="400"/>
+              </a:spcBef>
+              <a:defRPr sz="1400">
+                <a:solidFill>
+                  <a:srgbClr val="64748B"/>
+                </a:solidFill>
+              </a:defRPr>
+            </a:pPr>
+            <a:r>
+              <a:t>  Georgia Tax Credit — 30%</a:t>
+            </a:r>
+          </a:p>
+          <a:p>
+            <a:pPr>
+              <a:spcBef>
+                <a:spcPts val="400"/>
+              </a:spcBef>
+              <a:defRPr sz="1400">
+                <a:solidFill>
+                  <a:srgbClr val="64748B"/>
+                </a:solidFill>
+              </a:defRPr>
+            </a:pPr>
+            <a:r>
+              <a:t>  Hungary Cash Rebate — 30%</a:t>
+            </a:r>
+          </a:p>
+          <a:p>
+            <a:pPr>
+              <a:spcBef>
+                <a:spcPts val="400"/>
+              </a:spcBef>
+              <a:defRPr sz="1400">
+                <a:solidFill>
+                  <a:srgbClr val="64748B"/>
+                </a:solidFill>
+              </a:defRPr>
+            </a:pPr>
+            <a:r>
+              <a:t>  Australia PDV Offset — 30%</a:t>
+            </a:r>
+          </a:p>
+          <a:p>
+            <a:pPr>
+              <a:spcBef>
+                <a:spcPts val="400"/>
+              </a:spcBef>
+              <a:defRPr sz="1400">
+                <a:solidFill>
+                  <a:srgbClr val="64748B"/>
+                </a:solidFill>
+              </a:defRPr>
+            </a:pPr>
+          </a:p>
+          <a:p>
+            <a:pPr>
+              <a:spcBef>
+                <a:spcPts val="400"/>
+              </a:spcBef>
+              <a:defRPr sz="1400">
+                <a:solidFill>
+                  <a:srgbClr val="64748B"/>
+                </a:solidFill>
+              </a:defRPr>
+            </a:pPr>
+            <a:r>
+              <a:t>Built-in rebate calculator and eligibility filters</a:t>
             </a:r>
           </a:p>
         </p:txBody>
       </p:sp>
       <p:pic>
         <p:nvPicPr>
-          <p:cNvPr id="5" name="Picture 4" descr="15_chat_help.png"/>
+          <p:cNvPr id="5" name="Picture 4" descr="04_funding.png"/>
           <p:cNvPicPr>
             <a:picLocks noChangeAspect="1"/>
           </p:cNvPicPr>
@@ -4482,7 +4516,7 @@
         <p:spPr>
           <a:xfrm>
             <a:off x="6217920" y="1188720"/>
-            <a:ext cx="5303520" cy="3729038"/>
+            <a:ext cx="5303520" cy="5162989"/>
           </a:xfrm>
           <a:prstGeom prst="rect">
             <a:avLst/>
@@ -4615,7 +4649,7 @@
               </a:defRPr>
             </a:pPr>
             <a:r>
-              <a:t>Technical Summary</a:t>
+              <a:t>Deal Closing &amp; Data Room</a:t>
             </a:r>
           </a:p>
         </p:txBody>
@@ -4629,7 +4663,7 @@
         <p:spPr>
           <a:xfrm>
             <a:off x="731520" y="1188720"/>
-            <a:ext cx="10515600" cy="5029200"/>
+            <a:ext cx="5029200" cy="5029200"/>
           </a:xfrm>
           <a:prstGeom prst="rect">
             <a:avLst/>
@@ -4653,7 +4687,7 @@
               </a:defRPr>
             </a:pPr>
             <a:r>
-              <a:t>Production-grade architecture</a:t>
+              <a:t>Infrastructure layer for streamlined closings</a:t>
             </a:r>
           </a:p>
           <a:p>
@@ -4675,97 +4709,7 @@
               </a:defRPr>
             </a:pPr>
             <a:r>
-              <a:t>Frontend: FastHTML + HTMX (server-rendered, no React/JS frameworks)</a:t>
-            </a:r>
-          </a:p>
-          <a:p>
-            <a:pPr>
-              <a:spcBef>
-                <a:spcPts val="400"/>
-              </a:spcBef>
-              <a:defRPr sz="1400">
-                <a:solidFill>
-                  <a:srgbClr val="64748B"/>
-                </a:solidFill>
-              </a:defRPr>
-            </a:pPr>
-            <a:r>
-              <a:t>AI Engine: LangGraph + XAI Grok-3 (14 structured tools)</a:t>
-            </a:r>
-          </a:p>
-          <a:p>
-            <a:pPr>
-              <a:spcBef>
-                <a:spcPts val="400"/>
-              </a:spcBef>
-              <a:defRPr sz="1400">
-                <a:solidFill>
-                  <a:srgbClr val="64748B"/>
-                </a:solidFill>
-              </a:defRPr>
-            </a:pPr>
-            <a:r>
-              <a:t>Database: PostgreSQL (28 tables in ahmf schema)</a:t>
-            </a:r>
-          </a:p>
-          <a:p>
-            <a:pPr>
-              <a:spcBef>
-                <a:spcPts val="400"/>
-              </a:spcBef>
-              <a:defRPr sz="1400">
-                <a:solidFill>
-                  <a:srgbClr val="64748B"/>
-                </a:solidFill>
-              </a:defRPr>
-            </a:pPr>
-            <a:r>
-              <a:t>Film Data: TMDB + OMDB APIs (budgets, revenue, cast, ratings)</a:t>
-            </a:r>
-          </a:p>
-          <a:p>
-            <a:pPr>
-              <a:spcBef>
-                <a:spcPts val="400"/>
-              </a:spcBef>
-              <a:defRPr sz="1400">
-                <a:solidFill>
-                  <a:srgbClr val="64748B"/>
-                </a:solidFill>
-              </a:defRPr>
-            </a:pPr>
-            <a:r>
-              <a:t>Auth: Email/password + JWT session management</a:t>
-            </a:r>
-          </a:p>
-          <a:p>
-            <a:pPr>
-              <a:spcBef>
-                <a:spcPts val="400"/>
-              </a:spcBef>
-              <a:defRPr sz="1400">
-                <a:solidFill>
-                  <a:srgbClr val="64748B"/>
-                </a:solidFill>
-              </a:defRPr>
-            </a:pPr>
-            <a:r>
-              <a:t>Deployment: Docker + Coolify (auto-deploy on git push)</a:t>
-            </a:r>
-          </a:p>
-          <a:p>
-            <a:pPr>
-              <a:spcBef>
-                <a:spcPts val="400"/>
-              </a:spcBef>
-              <a:defRPr sz="1400">
-                <a:solidFill>
-                  <a:srgbClr val="64748B"/>
-                </a:solidFill>
-              </a:defRPr>
-            </a:pPr>
-            <a:r>
-              <a:t>Test Suite: 30 automated tests covering all modules</a:t>
+              <a:t>Auto-generated 20-item closing checklists</a:t>
             </a:r>
           </a:p>
           <a:p>
@@ -4792,14 +4736,155 @@
               </a:defRPr>
             </a:pPr>
             <a:r>
-              <a:t>All 9 roadmap products operational</a:t>
-            </a:r>
-          </a:p>
-        </p:txBody>
-      </p:sp>
-      <p:sp>
-        <p:nvSpPr>
-          <p:cNvPr id="5" name="TextBox 4"/>
+              <a:t>6 Categories:</a:t>
+            </a:r>
+          </a:p>
+          <a:p>
+            <a:pPr>
+              <a:spcBef>
+                <a:spcPts val="400"/>
+              </a:spcBef>
+              <a:defRPr sz="1400">
+                <a:solidFill>
+                  <a:srgbClr val="64748B"/>
+                </a:solidFill>
+              </a:defRPr>
+            </a:pPr>
+            <a:r>
+              <a:t>  Legal (5 items) — loan agreements, security, completion guarantee</a:t>
+            </a:r>
+          </a:p>
+          <a:p>
+            <a:pPr>
+              <a:spcBef>
+                <a:spcPts val="400"/>
+              </a:spcBef>
+              <a:defRPr sz="1400">
+                <a:solidFill>
+                  <a:srgbClr val="64748B"/>
+                </a:solidFill>
+              </a:defRPr>
+            </a:pPr>
+            <a:r>
+              <a:t>  Insurance (3 items) — E&amp;O, production insurance, completion bond</a:t>
+            </a:r>
+          </a:p>
+          <a:p>
+            <a:pPr>
+              <a:spcBef>
+                <a:spcPts val="400"/>
+              </a:spcBef>
+              <a:defRPr sz="1400">
+                <a:solidFill>
+                  <a:srgbClr val="64748B"/>
+                </a:solidFill>
+              </a:defRPr>
+            </a:pPr>
+            <a:r>
+              <a:t>  Financial (4 items) — chain of title, budget, lab access, CAMA</a:t>
+            </a:r>
+          </a:p>
+          <a:p>
+            <a:pPr>
+              <a:spcBef>
+                <a:spcPts val="400"/>
+              </a:spcBef>
+              <a:defRPr sz="1400">
+                <a:solidFill>
+                  <a:srgbClr val="64748B"/>
+                </a:solidFill>
+              </a:defRPr>
+            </a:pPr>
+            <a:r>
+              <a:t>  Distribution (3 items) — agreements, delivery schedule, MG commitments</a:t>
+            </a:r>
+          </a:p>
+          <a:p>
+            <a:pPr>
+              <a:spcBef>
+                <a:spcPts val="400"/>
+              </a:spcBef>
+              <a:defRPr sz="1400">
+                <a:solidFill>
+                  <a:srgbClr val="64748B"/>
+                </a:solidFill>
+              </a:defRPr>
+            </a:pPr>
+            <a:r>
+              <a:t>  Tax Incentives (2 items) — applications, auditor opinion</a:t>
+            </a:r>
+          </a:p>
+          <a:p>
+            <a:pPr>
+              <a:spcBef>
+                <a:spcPts val="400"/>
+              </a:spcBef>
+              <a:defRPr sz="1400">
+                <a:solidFill>
+                  <a:srgbClr val="64748B"/>
+                </a:solidFill>
+              </a:defRPr>
+            </a:pPr>
+            <a:r>
+              <a:t>  Compliance (3 items) — KYC/AML, OFAC, board approval</a:t>
+            </a:r>
+          </a:p>
+          <a:p>
+            <a:pPr>
+              <a:spcBef>
+                <a:spcPts val="400"/>
+              </a:spcBef>
+              <a:defRPr sz="1400">
+                <a:solidFill>
+                  <a:srgbClr val="64748B"/>
+                </a:solidFill>
+              </a:defRPr>
+            </a:pPr>
+          </a:p>
+          <a:p>
+            <a:pPr>
+              <a:spcBef>
+                <a:spcPts val="400"/>
+              </a:spcBef>
+              <a:defRPr sz="1400">
+                <a:solidFill>
+                  <a:srgbClr val="64748B"/>
+                </a:solidFill>
+              </a:defRPr>
+            </a:pPr>
+            <a:r>
+              <a:t>Interactive checkbox tracking with progress bars</a:t>
+            </a:r>
+          </a:p>
+        </p:txBody>
+      </p:sp>
+      <p:pic>
+        <p:nvPicPr>
+          <p:cNvPr id="5" name="Picture 4" descr="13_checklist.png"/>
+          <p:cNvPicPr>
+            <a:picLocks noChangeAspect="1"/>
+          </p:cNvPicPr>
+          <p:nvPr/>
+        </p:nvPicPr>
+        <p:blipFill>
+          <a:blip r:embed="rId2"/>
+          <a:stretch>
+            <a:fillRect/>
+          </a:stretch>
+        </p:blipFill>
+        <p:spPr>
+          <a:xfrm>
+            <a:off x="6217920" y="1188720"/>
+            <a:ext cx="5303520" cy="3729038"/>
+          </a:xfrm>
+          <a:prstGeom prst="rect">
+            <a:avLst/>
+          </a:prstGeom>
+        </p:spPr>
+      </p:pic>
+      <p:sp>
+        <p:nvSpPr>
+          <p:cNvPr id="6" name="TextBox 5"/>
           <p:cNvSpPr txBox="1"/>
           <p:nvPr/>
         </p:nvSpPr>
@@ -4923,7 +5008,7 @@
               </a:defRPr>
             </a:pPr>
             <a:r>
-              <a:t>Next Steps</a:t>
+              <a:t>Audience &amp; Marketing Intelligence</a:t>
             </a:r>
           </a:p>
         </p:txBody>
@@ -4937,7 +5022,7 @@
         <p:spPr>
           <a:xfrm>
             <a:off x="731520" y="1188720"/>
-            <a:ext cx="10515600" cy="5029200"/>
+            <a:ext cx="5029200" cy="5029200"/>
           </a:xfrm>
           <a:prstGeom prst="rect">
             <a:avLst/>
@@ -4961,7 +5046,7 @@
               </a:defRPr>
             </a:pPr>
             <a:r>
-              <a:t>Continued platform depth and integrations</a:t>
+              <a:t>Campaign simulator meets audience heat map</a:t>
             </a:r>
           </a:p>
           <a:p>
@@ -4983,89 +5068,128 @@
               </a:defRPr>
             </a:pPr>
             <a:r>
-              <a:t>Deepen Product 1: Full CRUD on Sales &amp; Collections, Credit Rating, Accounting</a:t>
-            </a:r>
-          </a:p>
-          <a:p>
-            <a:pPr>
-              <a:spcBef>
-                <a:spcPts val="400"/>
-              </a:spcBef>
-              <a:defRPr sz="1400">
-                <a:solidFill>
-                  <a:srgbClr val="64748B"/>
-                </a:solidFill>
-              </a:defRPr>
-            </a:pPr>
-            <a:r>
-              <a:t>Sales Estimate Pipeline: 5-node LangGraph pipeline (analyze &gt; comps &gt; territory &gt; forecast &gt; report)</a:t>
-            </a:r>
-          </a:p>
-          <a:p>
-            <a:pPr>
-              <a:spcBef>
-                <a:spcPts val="400"/>
-              </a:spcBef>
-              <a:defRPr sz="1400">
-                <a:solidFill>
-                  <a:srgbClr val="64748B"/>
-                </a:solidFill>
-              </a:defRPr>
-            </a:pPr>
-            <a:r>
-              <a:t>PDF Script Ingestion: Upload screenplays for automated analysis</a:t>
-            </a:r>
-          </a:p>
-          <a:p>
-            <a:pPr>
-              <a:spcBef>
-                <a:spcPts val="400"/>
-              </a:spcBef>
-              <a:defRPr sz="1400">
-                <a:solidFill>
-                  <a:srgbClr val="64748B"/>
-                </a:solidFill>
-              </a:defRPr>
-            </a:pPr>
-            <a:r>
-              <a:t>Closing Workflow Automation: Drawdown requests, digital signatures</a:t>
-            </a:r>
-          </a:p>
-          <a:p>
-            <a:pPr>
-              <a:spcBef>
-                <a:spcPts val="400"/>
-              </a:spcBef>
-              <a:defRPr sz="1400">
-                <a:solidFill>
-                  <a:srgbClr val="64748B"/>
-                </a:solidFill>
-              </a:defRPr>
-            </a:pPr>
-            <a:r>
-              <a:t>Portfolio Analytics Dashboard: IRR tracking, collection monitoring, variance analysis</a:t>
-            </a:r>
-          </a:p>
-          <a:p>
-            <a:pPr>
-              <a:spcBef>
-                <a:spcPts val="400"/>
-              </a:spcBef>
-              <a:defRPr sz="1400">
-                <a:solidFill>
-                  <a:srgbClr val="64748B"/>
-                </a:solidFill>
-              </a:defRPr>
-            </a:pPr>
-            <a:r>
-              <a:t>Mobile Responsive: Tablet-optimized layout for on-the-go deal review</a:t>
-            </a:r>
-          </a:p>
-        </p:txBody>
-      </p:sp>
-      <p:sp>
-        <p:nvSpPr>
-          <p:cNvPr id="5" name="TextBox 4"/>
+              <a:t>AI-powered audience segmentation (3-5 segments)</a:t>
+            </a:r>
+          </a:p>
+          <a:p>
+            <a:pPr>
+              <a:spcBef>
+                <a:spcPts val="400"/>
+              </a:spcBef>
+              <a:defRPr sz="1400">
+                <a:solidFill>
+                  <a:srgbClr val="64748B"/>
+                </a:solidFill>
+              </a:defRPr>
+            </a:pPr>
+            <a:r>
+              <a:t>Demographic + psychographic clustering with % share</a:t>
+            </a:r>
+          </a:p>
+          <a:p>
+            <a:pPr>
+              <a:spcBef>
+                <a:spcPts val="400"/>
+              </a:spcBef>
+              <a:defRPr sz="1400">
+                <a:solidFill>
+                  <a:srgbClr val="64748B"/>
+                </a:solidFill>
+              </a:defRPr>
+            </a:pPr>
+            <a:r>
+              <a:t>Marketing channel allocation and spend estimates</a:t>
+            </a:r>
+          </a:p>
+          <a:p>
+            <a:pPr>
+              <a:spcBef>
+                <a:spcPts val="400"/>
+              </a:spcBef>
+              <a:defRPr sz="1400">
+                <a:solidFill>
+                  <a:srgbClr val="64748B"/>
+                </a:solidFill>
+              </a:defRPr>
+            </a:pPr>
+            <a:r>
+              <a:t>Release window optimization</a:t>
+            </a:r>
+          </a:p>
+          <a:p>
+            <a:pPr>
+              <a:spcBef>
+                <a:spcPts val="400"/>
+              </a:spcBef>
+              <a:defRPr sz="1400">
+                <a:solidFill>
+                  <a:srgbClr val="64748B"/>
+                </a:solidFill>
+              </a:defRPr>
+            </a:pPr>
+            <a:r>
+              <a:t>Platform strategy (theatrical, streaming, hybrid)</a:t>
+            </a:r>
+          </a:p>
+          <a:p>
+            <a:pPr>
+              <a:spcBef>
+                <a:spcPts val="400"/>
+              </a:spcBef>
+              <a:defRPr sz="1400">
+                <a:solidFill>
+                  <a:srgbClr val="64748B"/>
+                </a:solidFill>
+              </a:defRPr>
+            </a:pPr>
+            <a:r>
+              <a:t>Festival positioning recommendations</a:t>
+            </a:r>
+          </a:p>
+          <a:p>
+            <a:pPr>
+              <a:spcBef>
+                <a:spcPts val="400"/>
+              </a:spcBef>
+              <a:defRPr sz="1400">
+                <a:solidFill>
+                  <a:srgbClr val="64748B"/>
+                </a:solidFill>
+              </a:defRPr>
+            </a:pPr>
+            <a:r>
+              <a:t>Comparable film marketing analysis</a:t>
+            </a:r>
+          </a:p>
+        </p:txBody>
+      </p:sp>
+      <p:pic>
+        <p:nvPicPr>
+          <p:cNvPr id="5" name="Picture 4" descr="11_audience.png"/>
+          <p:cNvPicPr>
+            <a:picLocks noChangeAspect="1"/>
+          </p:cNvPicPr>
+          <p:nvPr/>
+        </p:nvPicPr>
+        <p:blipFill>
+          <a:blip r:embed="rId2"/>
+          <a:stretch>
+            <a:fillRect/>
+          </a:stretch>
+        </p:blipFill>
+        <p:spPr>
+          <a:xfrm>
+            <a:off x="6217920" y="1188720"/>
+            <a:ext cx="5303520" cy="3729038"/>
+          </a:xfrm>
+          <a:prstGeom prst="rect">
+            <a:avLst/>
+          </a:prstGeom>
+        </p:spPr>
+      </p:pic>
+      <p:sp>
+        <p:nvSpPr>
+          <p:cNvPr id="6" name="TextBox 5"/>
           <p:cNvSpPr txBox="1"/>
           <p:nvPr/>
         </p:nvSpPr>
@@ -5109,14 +5233,6 @@
 <file path=ppt/slides/slide16.xml><?xml version="1.0" encoding="utf-8"?>
 <p:sld xmlns:a="http://schemas.openxmlformats.org/drawingml/2006/main" xmlns:p="http://schemas.openxmlformats.org/presentationml/2006/main" xmlns:r="http://schemas.openxmlformats.org/officeDocument/2006/relationships">
   <p:cSld>
-    <p:bg>
-      <p:bgPr>
-        <a:solidFill>
-          <a:srgbClr val="0066CC"/>
-        </a:solidFill>
-        <a:effectLst/>
-      </p:bgPr>
-    </p:bg>
     <p:spTree>
       <p:nvGrpSpPr>
         <p:cNvPr id="1" name=""/>
@@ -5126,14 +5242,92 @@
       <p:grpSpPr/>
       <p:sp>
         <p:nvSpPr>
-          <p:cNvPr id="2" name="TextBox 1"/>
+          <p:cNvPr id="2" name="Rectangle 1"/>
+          <p:cNvSpPr/>
+          <p:nvPr/>
+        </p:nvSpPr>
+        <p:spPr>
+          <a:xfrm>
+            <a:off x="0" y="0"/>
+            <a:ext cx="12191695" cy="73152"/>
+          </a:xfrm>
+          <a:prstGeom prst="rect">
+            <a:avLst/>
+          </a:prstGeom>
+          <a:solidFill>
+            <a:srgbClr val="0066CC"/>
+          </a:solidFill>
+          <a:ln>
+            <a:noFill/>
+          </a:ln>
+        </p:spPr>
+        <p:style>
+          <a:lnRef idx="1">
+            <a:schemeClr val="accent1"/>
+          </a:lnRef>
+          <a:fillRef idx="3">
+            <a:schemeClr val="accent1"/>
+          </a:fillRef>
+          <a:effectRef idx="2">
+            <a:schemeClr val="accent1"/>
+          </a:effectRef>
+          <a:fontRef idx="minor">
+            <a:schemeClr val="lt1"/>
+          </a:fontRef>
+        </p:style>
+        <p:txBody>
+          <a:bodyPr rtlCol="0" anchor="ctr"/>
+          <a:lstStyle/>
+          <a:p>
+            <a:pPr algn="ctr"/>
+          </a:p>
+        </p:txBody>
+      </p:sp>
+      <p:sp>
+        <p:nvSpPr>
+          <p:cNvPr id="3" name="TextBox 2"/>
           <p:cNvSpPr txBox="1"/>
           <p:nvPr/>
         </p:nvSpPr>
         <p:spPr>
           <a:xfrm>
-            <a:off x="914400" y="1828800"/>
-            <a:ext cx="10058400" cy="1828800"/>
+            <a:off x="731520" y="274320"/>
+            <a:ext cx="10058400" cy="731520"/>
+          </a:xfrm>
+          <a:prstGeom prst="rect">
+            <a:avLst/>
+          </a:prstGeom>
+          <a:noFill/>
+        </p:spPr>
+        <p:txBody>
+          <a:bodyPr wrap="none">
+            <a:spAutoFit/>
+          </a:bodyPr>
+          <a:lstStyle/>
+          <a:p>
+            <a:pPr>
+              <a:defRPr sz="2800" b="1">
+                <a:solidFill>
+                  <a:srgbClr val="1E293B"/>
+                </a:solidFill>
+              </a:defRPr>
+            </a:pPr>
+            <a:r>
+              <a:t>Talent Intelligence</a:t>
+            </a:r>
+          </a:p>
+        </p:txBody>
+      </p:sp>
+      <p:sp>
+        <p:nvSpPr>
+          <p:cNvPr id="4" name="TextBox 3"/>
+          <p:cNvSpPr txBox="1"/>
+          <p:nvPr/>
+        </p:nvSpPr>
+        <p:spPr>
+          <a:xfrm>
+            <a:off x="731520" y="1188720"/>
+            <a:ext cx="5029200" cy="5029200"/>
           </a:xfrm>
           <a:prstGeom prst="rect">
             <a:avLst/>
@@ -5147,34 +5341,277 @@
           <a:lstStyle/>
           <a:p>
             <a:pPr>
-              <a:defRPr sz="4400" b="1">
-                <a:solidFill>
-                  <a:srgbClr val="FFFFFF"/>
-                </a:solidFill>
-              </a:defRPr>
-            </a:pPr>
-            <a:r>
-              <a:t>Thank You</a:t>
-            </a:r>
-          </a:p>
-          <a:p>
-            <a:pPr>
-              <a:spcBef>
-                <a:spcPts val="2000"/>
-              </a:spcBef>
-              <a:defRPr sz="2000">
-                <a:solidFill>
-                  <a:srgbClr val="FFFFFF"/>
-                </a:solidFill>
-              </a:defRPr>
-            </a:pPr>
-            <a:r>
-              <a:t>Joe Simpson — Managing Partner</a:t>
-            </a:r>
-            <a:br/>
-            <a:r>
-              <a:t>Ashland Hill Media Finance</a:t>
-            </a:r>
+              <a:spcBef>
+                <a:spcPts val="1200"/>
+              </a:spcBef>
+              <a:defRPr sz="1600" b="1">
+                <a:solidFill>
+                  <a:srgbClr val="1E293B"/>
+                </a:solidFill>
+              </a:defRPr>
+            </a:pPr>
+            <a:r>
+              <a:t>Taste graph meets market intelligence</a:t>
+            </a:r>
+          </a:p>
+          <a:p>
+            <a:pPr>
+              <a:spcBef>
+                <a:spcPts val="800"/>
+              </a:spcBef>
+            </a:pPr>
+          </a:p>
+          <a:p>
+            <a:pPr>
+              <a:spcBef>
+                <a:spcPts val="400"/>
+              </a:spcBef>
+              <a:defRPr sz="1400">
+                <a:solidFill>
+                  <a:srgbClr val="64748B"/>
+                </a:solidFill>
+              </a:defRPr>
+            </a:pPr>
+            <a:r>
+              <a:t>Live TMDB actor/director search with popularity data</a:t>
+            </a:r>
+          </a:p>
+          <a:p>
+            <a:pPr>
+              <a:spcBef>
+                <a:spcPts val="400"/>
+              </a:spcBef>
+              <a:defRPr sz="1400">
+                <a:solidFill>
+                  <a:srgbClr val="64748B"/>
+                </a:solidFill>
+              </a:defRPr>
+            </a:pPr>
+            <a:r>
+              <a:t>AI cast recommendations scored on:</a:t>
+            </a:r>
+          </a:p>
+          <a:p>
+            <a:pPr>
+              <a:spcBef>
+                <a:spcPts val="400"/>
+              </a:spcBef>
+              <a:defRPr sz="1400">
+                <a:solidFill>
+                  <a:srgbClr val="64748B"/>
+                </a:solidFill>
+              </a:defRPr>
+            </a:pPr>
+            <a:r>
+              <a:t>  Heat Index (1-10) — current market popularity</a:t>
+            </a:r>
+          </a:p>
+          <a:p>
+            <a:pPr>
+              <a:spcBef>
+                <a:spcPts val="400"/>
+              </a:spcBef>
+              <a:defRPr sz="1400">
+                <a:solidFill>
+                  <a:srgbClr val="64748B"/>
+                </a:solidFill>
+              </a:defRPr>
+            </a:pPr>
+            <a:r>
+              <a:t>  Genre Fit (1-10) — alignment with project tone</a:t>
+            </a:r>
+          </a:p>
+          <a:p>
+            <a:pPr>
+              <a:spcBef>
+                <a:spcPts val="400"/>
+              </a:spcBef>
+              <a:defRPr sz="1400">
+                <a:solidFill>
+                  <a:srgbClr val="64748B"/>
+                </a:solidFill>
+              </a:defRPr>
+            </a:pPr>
+            <a:r>
+              <a:t>  Salary Tier — Low / Mid / High / Premium</a:t>
+            </a:r>
+          </a:p>
+          <a:p>
+            <a:pPr>
+              <a:spcBef>
+                <a:spcPts val="400"/>
+              </a:spcBef>
+              <a:defRPr sz="1400">
+                <a:solidFill>
+                  <a:srgbClr val="64748B"/>
+                </a:solidFill>
+              </a:defRPr>
+            </a:pPr>
+            <a:r>
+              <a:t>  International Sales Impact — Low / Mid / High</a:t>
+            </a:r>
+          </a:p>
+          <a:p>
+            <a:pPr>
+              <a:spcBef>
+                <a:spcPts val="400"/>
+              </a:spcBef>
+              <a:defRPr sz="1400">
+                <a:solidFill>
+                  <a:srgbClr val="64748B"/>
+                </a:solidFill>
+              </a:defRPr>
+            </a:pPr>
+          </a:p>
+          <a:p>
+            <a:pPr>
+              <a:spcBef>
+                <a:spcPts val="400"/>
+              </a:spcBef>
+              <a:defRPr sz="1400">
+                <a:solidFill>
+                  <a:srgbClr val="64748B"/>
+                </a:solidFill>
+              </a:defRPr>
+            </a:pPr>
+            <a:r>
+              <a:t>Package simulation: test cast combinations for projected revenue</a:t>
+            </a:r>
+          </a:p>
+          <a:p>
+            <a:pPr>
+              <a:spcBef>
+                <a:spcPts val="400"/>
+              </a:spcBef>
+              <a:defRPr sz="1400">
+                <a:solidFill>
+                  <a:srgbClr val="64748B"/>
+                </a:solidFill>
+              </a:defRPr>
+            </a:pPr>
+            <a:r>
+              <a:t>Comparable role analysis from filmography data</a:t>
+            </a:r>
+          </a:p>
+        </p:txBody>
+      </p:sp>
+      <p:pic>
+        <p:nvPicPr>
+          <p:cNvPr id="5" name="Picture 4" descr="14_talent_search.png"/>
+          <p:cNvPicPr>
+            <a:picLocks noChangeAspect="1"/>
+          </p:cNvPicPr>
+          <p:nvPr/>
+        </p:nvPicPr>
+        <p:blipFill>
+          <a:blip r:embed="rId2"/>
+          <a:stretch>
+            <a:fillRect/>
+          </a:stretch>
+        </p:blipFill>
+        <p:spPr>
+          <a:xfrm>
+            <a:off x="6217920" y="1188720"/>
+            <a:ext cx="5303520" cy="5162989"/>
+          </a:xfrm>
+          <a:prstGeom prst="rect">
+            <a:avLst/>
+          </a:prstGeom>
+        </p:spPr>
+      </p:pic>
+      <p:sp>
+        <p:nvSpPr>
+          <p:cNvPr id="6" name="TextBox 5"/>
+          <p:cNvSpPr txBox="1"/>
+          <p:nvPr/>
+        </p:nvSpPr>
+        <p:spPr>
+          <a:xfrm>
+            <a:off x="731520" y="6400800"/>
+            <a:ext cx="4572000" cy="274320"/>
+          </a:xfrm>
+          <a:prstGeom prst="rect">
+            <a:avLst/>
+          </a:prstGeom>
+          <a:noFill/>
+        </p:spPr>
+        <p:txBody>
+          <a:bodyPr wrap="none">
+            <a:spAutoFit/>
+          </a:bodyPr>
+          <a:lstStyle/>
+          <a:p>
+            <a:pPr>
+              <a:defRPr sz="800">
+                <a:solidFill>
+                  <a:srgbClr val="64748B"/>
+                </a:solidFill>
+              </a:defRPr>
+            </a:pPr>
+            <a:r>
+              <a:t>Ashland Hill Media Finance — Private &amp; Confidential</a:t>
+            </a:r>
+          </a:p>
+        </p:txBody>
+      </p:sp>
+    </p:spTree>
+  </p:cSld>
+  <p:clrMapOvr>
+    <a:masterClrMapping/>
+  </p:clrMapOvr>
+</p:sld>
+</file>
+
+<file path=ppt/slides/slide17.xml><?xml version="1.0" encoding="utf-8"?>
+<p:sld xmlns:a="http://schemas.openxmlformats.org/drawingml/2006/main" xmlns:p="http://schemas.openxmlformats.org/presentationml/2006/main" xmlns:r="http://schemas.openxmlformats.org/officeDocument/2006/relationships">
+  <p:cSld>
+    <p:spTree>
+      <p:nvGrpSpPr>
+        <p:cNvPr id="1" name=""/>
+        <p:cNvGrpSpPr/>
+        <p:nvPr/>
+      </p:nvGrpSpPr>
+      <p:grpSpPr/>
+      <p:sp>
+        <p:nvSpPr>
+          <p:cNvPr id="2" name="Rectangle 1"/>
+          <p:cNvSpPr/>
+          <p:nvPr/>
+        </p:nvSpPr>
+        <p:spPr>
+          <a:xfrm>
+            <a:off x="0" y="0"/>
+            <a:ext cx="12191695" cy="73152"/>
+          </a:xfrm>
+          <a:prstGeom prst="rect">
+            <a:avLst/>
+          </a:prstGeom>
+          <a:solidFill>
+            <a:srgbClr val="0066CC"/>
+          </a:solidFill>
+          <a:ln>
+            <a:noFill/>
+          </a:ln>
+        </p:spPr>
+        <p:style>
+          <a:lnRef idx="1">
+            <a:schemeClr val="accent1"/>
+          </a:lnRef>
+          <a:fillRef idx="3">
+            <a:schemeClr val="accent1"/>
+          </a:fillRef>
+          <a:effectRef idx="2">
+            <a:schemeClr val="accent1"/>
+          </a:effectRef>
+          <a:fontRef idx="minor">
+            <a:schemeClr val="lt1"/>
+          </a:fontRef>
+        </p:style>
+        <p:txBody>
+          <a:bodyPr rtlCol="0" anchor="ctr"/>
+          <a:lstStyle/>
+          <a:p>
+            <a:pPr algn="ctr"/>
           </a:p>
         </p:txBody>
       </p:sp>
@@ -5186,8 +5623,8 @@
         </p:nvSpPr>
         <p:spPr>
           <a:xfrm>
-            <a:off x="914400" y="5029200"/>
-            <a:ext cx="2743200" cy="457200"/>
+            <a:off x="731520" y="274320"/>
+            <a:ext cx="10058400" cy="731520"/>
           </a:xfrm>
           <a:prstGeom prst="rect">
             <a:avLst/>
@@ -5201,14 +5638,824 @@
           <a:lstStyle/>
           <a:p>
             <a:pPr>
-              <a:defRPr sz="1400" b="1">
-                <a:solidFill>
-                  <a:srgbClr val="FFFFFF"/>
-                </a:solidFill>
-              </a:defRPr>
-            </a:pPr>
-            <a:r>
-              <a:t>Ashland Hill Media Finance</a:t>
+              <a:defRPr sz="2800" b="1">
+                <a:solidFill>
+                  <a:srgbClr val="1E293B"/>
+                </a:solidFill>
+              </a:defRPr>
+            </a:pPr>
+            <a:r>
+              <a:t>AI Chat — The Intelligence Layer</a:t>
+            </a:r>
+          </a:p>
+        </p:txBody>
+      </p:sp>
+      <p:sp>
+        <p:nvSpPr>
+          <p:cNvPr id="4" name="TextBox 3"/>
+          <p:cNvSpPr txBox="1"/>
+          <p:nvPr/>
+        </p:nvSpPr>
+        <p:spPr>
+          <a:xfrm>
+            <a:off x="731520" y="1188720"/>
+            <a:ext cx="5029200" cy="5029200"/>
+          </a:xfrm>
+          <a:prstGeom prst="rect">
+            <a:avLst/>
+          </a:prstGeom>
+          <a:noFill/>
+        </p:spPr>
+        <p:txBody>
+          <a:bodyPr wrap="square">
+            <a:spAutoFit/>
+          </a:bodyPr>
+          <a:lstStyle/>
+          <a:p>
+            <a:pPr>
+              <a:spcBef>
+                <a:spcPts val="1200"/>
+              </a:spcBef>
+              <a:defRPr sz="1600" b="1">
+                <a:solidFill>
+                  <a:srgbClr val="1E293B"/>
+                </a:solidFill>
+              </a:defRPr>
+            </a:pPr>
+            <a:r>
+              <a:t>18 AI tools accessible via natural language or structured commands</a:t>
+            </a:r>
+          </a:p>
+          <a:p>
+            <a:pPr>
+              <a:spcBef>
+                <a:spcPts val="800"/>
+              </a:spcBef>
+            </a:pPr>
+          </a:p>
+          <a:p>
+            <a:pPr>
+              <a:spcBef>
+                <a:spcPts val="400"/>
+              </a:spcBef>
+              <a:defRPr sz="1400">
+                <a:solidFill>
+                  <a:srgbClr val="64748B"/>
+                </a:solidFill>
+              </a:defRPr>
+            </a:pPr>
+            <a:r>
+              <a:t>deal:list / portfolio — Deal pipeline and portfolio analytics</a:t>
+            </a:r>
+          </a:p>
+          <a:p>
+            <a:pPr>
+              <a:spcBef>
+                <a:spcPts val="400"/>
+              </a:spcBef>
+              <a:defRPr sz="1400">
+                <a:solidFill>
+                  <a:srgbClr val="64748B"/>
+                </a:solidFill>
+              </a:defRPr>
+            </a:pPr>
+            <a:r>
+              <a:t>contact:search / credit:NAME — Contacts and credit ratings</a:t>
+            </a:r>
+          </a:p>
+          <a:p>
+            <a:pPr>
+              <a:spcBef>
+                <a:spcPts val="400"/>
+              </a:spcBef>
+              <a:defRPr sz="1400">
+                <a:solidFill>
+                  <a:srgbClr val="64748B"/>
+                </a:solidFill>
+              </a:defRPr>
+            </a:pPr>
+            <a:r>
+              <a:t>sales:list / transactions / messages — Financial operations</a:t>
+            </a:r>
+          </a:p>
+          <a:p>
+            <a:pPr>
+              <a:spcBef>
+                <a:spcPts val="400"/>
+              </a:spcBef>
+              <a:defRPr sz="1400">
+                <a:solidFill>
+                  <a:srgbClr val="64748B"/>
+                </a:solidFill>
+              </a:defRPr>
+            </a:pPr>
+            <a:r>
+              <a:t>incentives — Search global film tax incentives</a:t>
+            </a:r>
+          </a:p>
+          <a:p>
+            <a:pPr>
+              <a:spcBef>
+                <a:spcPts val="400"/>
+              </a:spcBef>
+              <a:defRPr sz="1400">
+                <a:solidFill>
+                  <a:srgbClr val="64748B"/>
+                </a:solidFill>
+              </a:defRPr>
+            </a:pPr>
+            <a:r>
+              <a:t>talent:search NAME — Look up actors/directors via TMDB</a:t>
+            </a:r>
+          </a:p>
+          <a:p>
+            <a:pPr>
+              <a:spcBef>
+                <a:spcPts val="400"/>
+              </a:spcBef>
+              <a:defRPr sz="1400">
+                <a:solidFill>
+                  <a:srgbClr val="64748B"/>
+                </a:solidFill>
+              </a:defRPr>
+            </a:pPr>
+            <a:r>
+              <a:t>risk:new / budget:new / schedule:new — AI analysis tools</a:t>
+            </a:r>
+          </a:p>
+          <a:p>
+            <a:pPr>
+              <a:spcBef>
+                <a:spcPts val="400"/>
+              </a:spcBef>
+              <a:defRPr sz="1400">
+                <a:solidFill>
+                  <a:srgbClr val="64748B"/>
+                </a:solidFill>
+              </a:defRPr>
+            </a:pPr>
+            <a:r>
+              <a:t>audience:new — Audience &amp; marketing prediction</a:t>
+            </a:r>
+          </a:p>
+          <a:p>
+            <a:pPr>
+              <a:spcBef>
+                <a:spcPts val="400"/>
+              </a:spcBef>
+              <a:defRPr sz="1400">
+                <a:solidFill>
+                  <a:srgbClr val="64748B"/>
+                </a:solidFill>
+              </a:defRPr>
+            </a:pPr>
+          </a:p>
+          <a:p>
+            <a:pPr>
+              <a:spcBef>
+                <a:spcPts val="400"/>
+              </a:spcBef>
+              <a:defRPr sz="1400">
+                <a:solidFill>
+                  <a:srgbClr val="64748B"/>
+                </a:solidFill>
+              </a:defRPr>
+            </a:pPr>
+            <a:r>
+              <a:t>Or ask any question in natural language — AI routes to the right tool</a:t>
+            </a:r>
+          </a:p>
+        </p:txBody>
+      </p:sp>
+      <p:pic>
+        <p:nvPicPr>
+          <p:cNvPr id="5" name="Picture 4" descr="15_chat_help.png"/>
+          <p:cNvPicPr>
+            <a:picLocks noChangeAspect="1"/>
+          </p:cNvPicPr>
+          <p:nvPr/>
+        </p:nvPicPr>
+        <p:blipFill>
+          <a:blip r:embed="rId2"/>
+          <a:stretch>
+            <a:fillRect/>
+          </a:stretch>
+        </p:blipFill>
+        <p:spPr>
+          <a:xfrm>
+            <a:off x="6217920" y="1188720"/>
+            <a:ext cx="5303520" cy="3729038"/>
+          </a:xfrm>
+          <a:prstGeom prst="rect">
+            <a:avLst/>
+          </a:prstGeom>
+        </p:spPr>
+      </p:pic>
+      <p:sp>
+        <p:nvSpPr>
+          <p:cNvPr id="6" name="TextBox 5"/>
+          <p:cNvSpPr txBox="1"/>
+          <p:nvPr/>
+        </p:nvSpPr>
+        <p:spPr>
+          <a:xfrm>
+            <a:off x="731520" y="6400800"/>
+            <a:ext cx="4572000" cy="274320"/>
+          </a:xfrm>
+          <a:prstGeom prst="rect">
+            <a:avLst/>
+          </a:prstGeom>
+          <a:noFill/>
+        </p:spPr>
+        <p:txBody>
+          <a:bodyPr wrap="none">
+            <a:spAutoFit/>
+          </a:bodyPr>
+          <a:lstStyle/>
+          <a:p>
+            <a:pPr>
+              <a:defRPr sz="800">
+                <a:solidFill>
+                  <a:srgbClr val="64748B"/>
+                </a:solidFill>
+              </a:defRPr>
+            </a:pPr>
+            <a:r>
+              <a:t>Ashland Hill Media Finance — Private &amp; Confidential</a:t>
+            </a:r>
+          </a:p>
+        </p:txBody>
+      </p:sp>
+    </p:spTree>
+  </p:cSld>
+  <p:clrMapOvr>
+    <a:masterClrMapping/>
+  </p:clrMapOvr>
+</p:sld>
+</file>
+
+<file path=ppt/slides/slide18.xml><?xml version="1.0" encoding="utf-8"?>
+<p:sld xmlns:a="http://schemas.openxmlformats.org/drawingml/2006/main" xmlns:p="http://schemas.openxmlformats.org/presentationml/2006/main" xmlns:r="http://schemas.openxmlformats.org/officeDocument/2006/relationships">
+  <p:cSld>
+    <p:spTree>
+      <p:nvGrpSpPr>
+        <p:cNvPr id="1" name=""/>
+        <p:cNvGrpSpPr/>
+        <p:nvPr/>
+      </p:nvGrpSpPr>
+      <p:grpSpPr/>
+      <p:sp>
+        <p:nvSpPr>
+          <p:cNvPr id="2" name="Rectangle 1"/>
+          <p:cNvSpPr/>
+          <p:nvPr/>
+        </p:nvSpPr>
+        <p:spPr>
+          <a:xfrm>
+            <a:off x="0" y="0"/>
+            <a:ext cx="12191695" cy="73152"/>
+          </a:xfrm>
+          <a:prstGeom prst="rect">
+            <a:avLst/>
+          </a:prstGeom>
+          <a:solidFill>
+            <a:srgbClr val="0066CC"/>
+          </a:solidFill>
+          <a:ln>
+            <a:noFill/>
+          </a:ln>
+        </p:spPr>
+        <p:style>
+          <a:lnRef idx="1">
+            <a:schemeClr val="accent1"/>
+          </a:lnRef>
+          <a:fillRef idx="3">
+            <a:schemeClr val="accent1"/>
+          </a:fillRef>
+          <a:effectRef idx="2">
+            <a:schemeClr val="accent1"/>
+          </a:effectRef>
+          <a:fontRef idx="minor">
+            <a:schemeClr val="lt1"/>
+          </a:fontRef>
+        </p:style>
+        <p:txBody>
+          <a:bodyPr rtlCol="0" anchor="ctr"/>
+          <a:lstStyle/>
+          <a:p>
+            <a:pPr algn="ctr"/>
+          </a:p>
+        </p:txBody>
+      </p:sp>
+      <p:sp>
+        <p:nvSpPr>
+          <p:cNvPr id="3" name="TextBox 2"/>
+          <p:cNvSpPr txBox="1"/>
+          <p:nvPr/>
+        </p:nvSpPr>
+        <p:spPr>
+          <a:xfrm>
+            <a:off x="731520" y="274320"/>
+            <a:ext cx="10058400" cy="731520"/>
+          </a:xfrm>
+          <a:prstGeom prst="rect">
+            <a:avLst/>
+          </a:prstGeom>
+          <a:noFill/>
+        </p:spPr>
+        <p:txBody>
+          <a:bodyPr wrap="none">
+            <a:spAutoFit/>
+          </a:bodyPr>
+          <a:lstStyle/>
+          <a:p>
+            <a:pPr>
+              <a:defRPr sz="2800" b="1">
+                <a:solidFill>
+                  <a:srgbClr val="1E293B"/>
+                </a:solidFill>
+              </a:defRPr>
+            </a:pPr>
+            <a:r>
+              <a:t>Technical Summary</a:t>
+            </a:r>
+          </a:p>
+        </p:txBody>
+      </p:sp>
+      <p:sp>
+        <p:nvSpPr>
+          <p:cNvPr id="4" name="TextBox 3"/>
+          <p:cNvSpPr txBox="1"/>
+          <p:nvPr/>
+        </p:nvSpPr>
+        <p:spPr>
+          <a:xfrm>
+            <a:off x="731520" y="1188720"/>
+            <a:ext cx="10515600" cy="5029200"/>
+          </a:xfrm>
+          <a:prstGeom prst="rect">
+            <a:avLst/>
+          </a:prstGeom>
+          <a:noFill/>
+        </p:spPr>
+        <p:txBody>
+          <a:bodyPr wrap="square">
+            <a:spAutoFit/>
+          </a:bodyPr>
+          <a:lstStyle/>
+          <a:p>
+            <a:pPr>
+              <a:spcBef>
+                <a:spcPts val="1200"/>
+              </a:spcBef>
+              <a:defRPr sz="1600" b="1">
+                <a:solidFill>
+                  <a:srgbClr val="1E293B"/>
+                </a:solidFill>
+              </a:defRPr>
+            </a:pPr>
+            <a:r>
+              <a:t>Production-grade architecture</a:t>
+            </a:r>
+          </a:p>
+          <a:p>
+            <a:pPr>
+              <a:spcBef>
+                <a:spcPts val="800"/>
+              </a:spcBef>
+            </a:pPr>
+          </a:p>
+          <a:p>
+            <a:pPr>
+              <a:spcBef>
+                <a:spcPts val="400"/>
+              </a:spcBef>
+              <a:defRPr sz="1400">
+                <a:solidFill>
+                  <a:srgbClr val="64748B"/>
+                </a:solidFill>
+              </a:defRPr>
+            </a:pPr>
+            <a:r>
+              <a:t>Frontend: FastHTML + HTMX (server-rendered, no React/JS frameworks)</a:t>
+            </a:r>
+          </a:p>
+          <a:p>
+            <a:pPr>
+              <a:spcBef>
+                <a:spcPts val="400"/>
+              </a:spcBef>
+              <a:defRPr sz="1400">
+                <a:solidFill>
+                  <a:srgbClr val="64748B"/>
+                </a:solidFill>
+              </a:defRPr>
+            </a:pPr>
+            <a:r>
+              <a:t>AI Engine: LangGraph + XAI Grok-3 (18 structured tools)</a:t>
+            </a:r>
+          </a:p>
+          <a:p>
+            <a:pPr>
+              <a:spcBef>
+                <a:spcPts val="400"/>
+              </a:spcBef>
+              <a:defRPr sz="1400">
+                <a:solidFill>
+                  <a:srgbClr val="64748B"/>
+                </a:solidFill>
+              </a:defRPr>
+            </a:pPr>
+            <a:r>
+              <a:t>Database: PostgreSQL (28 tables in ahmf schema)</a:t>
+            </a:r>
+          </a:p>
+          <a:p>
+            <a:pPr>
+              <a:spcBef>
+                <a:spcPts val="400"/>
+              </a:spcBef>
+              <a:defRPr sz="1400">
+                <a:solidFill>
+                  <a:srgbClr val="64748B"/>
+                </a:solidFill>
+              </a:defRPr>
+            </a:pPr>
+            <a:r>
+              <a:t>Film Data: TMDB + OMDB APIs (budgets, revenue, cast, ratings)</a:t>
+            </a:r>
+          </a:p>
+          <a:p>
+            <a:pPr>
+              <a:spcBef>
+                <a:spcPts val="400"/>
+              </a:spcBef>
+              <a:defRPr sz="1400">
+                <a:solidFill>
+                  <a:srgbClr val="64748B"/>
+                </a:solidFill>
+              </a:defRPr>
+            </a:pPr>
+            <a:r>
+              <a:t>Auth: Email/password + JWT session management</a:t>
+            </a:r>
+          </a:p>
+          <a:p>
+            <a:pPr>
+              <a:spcBef>
+                <a:spcPts val="400"/>
+              </a:spcBef>
+              <a:defRPr sz="1400">
+                <a:solidFill>
+                  <a:srgbClr val="64748B"/>
+                </a:solidFill>
+              </a:defRPr>
+            </a:pPr>
+            <a:r>
+              <a:t>Deployment: Docker + Coolify (auto-deploy on git push)</a:t>
+            </a:r>
+          </a:p>
+          <a:p>
+            <a:pPr>
+              <a:spcBef>
+                <a:spcPts val="400"/>
+              </a:spcBef>
+              <a:defRPr sz="1400">
+                <a:solidFill>
+                  <a:srgbClr val="64748B"/>
+                </a:solidFill>
+              </a:defRPr>
+            </a:pPr>
+            <a:r>
+              <a:t>Test Suite: 30 automated tests covering all modules</a:t>
+            </a:r>
+          </a:p>
+          <a:p>
+            <a:pPr>
+              <a:spcBef>
+                <a:spcPts val="400"/>
+              </a:spcBef>
+              <a:defRPr sz="1400">
+                <a:solidFill>
+                  <a:srgbClr val="64748B"/>
+                </a:solidFill>
+              </a:defRPr>
+            </a:pPr>
+          </a:p>
+          <a:p>
+            <a:pPr>
+              <a:spcBef>
+                <a:spcPts val="1200"/>
+              </a:spcBef>
+              <a:defRPr sz="1600" b="1">
+                <a:solidFill>
+                  <a:srgbClr val="1E293B"/>
+                </a:solidFill>
+              </a:defRPr>
+            </a:pPr>
+            <a:r>
+              <a:t>All 9 roadmap products fully operational — no placeholders</a:t>
+            </a:r>
+          </a:p>
+        </p:txBody>
+      </p:sp>
+      <p:sp>
+        <p:nvSpPr>
+          <p:cNvPr id="5" name="TextBox 4"/>
+          <p:cNvSpPr txBox="1"/>
+          <p:nvPr/>
+        </p:nvSpPr>
+        <p:spPr>
+          <a:xfrm>
+            <a:off x="731520" y="6400800"/>
+            <a:ext cx="4572000" cy="274320"/>
+          </a:xfrm>
+          <a:prstGeom prst="rect">
+            <a:avLst/>
+          </a:prstGeom>
+          <a:noFill/>
+        </p:spPr>
+        <p:txBody>
+          <a:bodyPr wrap="none">
+            <a:spAutoFit/>
+          </a:bodyPr>
+          <a:lstStyle/>
+          <a:p>
+            <a:pPr>
+              <a:defRPr sz="800">
+                <a:solidFill>
+                  <a:srgbClr val="64748B"/>
+                </a:solidFill>
+              </a:defRPr>
+            </a:pPr>
+            <a:r>
+              <a:t>Ashland Hill Media Finance — Private &amp; Confidential</a:t>
+            </a:r>
+          </a:p>
+        </p:txBody>
+      </p:sp>
+    </p:spTree>
+  </p:cSld>
+  <p:clrMapOvr>
+    <a:masterClrMapping/>
+  </p:clrMapOvr>
+</p:sld>
+</file>
+
+<file path=ppt/slides/slide19.xml><?xml version="1.0" encoding="utf-8"?>
+<p:sld xmlns:a="http://schemas.openxmlformats.org/drawingml/2006/main" xmlns:p="http://schemas.openxmlformats.org/presentationml/2006/main" xmlns:r="http://schemas.openxmlformats.org/officeDocument/2006/relationships">
+  <p:cSld>
+    <p:spTree>
+      <p:nvGrpSpPr>
+        <p:cNvPr id="1" name=""/>
+        <p:cNvGrpSpPr/>
+        <p:nvPr/>
+      </p:nvGrpSpPr>
+      <p:grpSpPr/>
+      <p:sp>
+        <p:nvSpPr>
+          <p:cNvPr id="2" name="Rectangle 1"/>
+          <p:cNvSpPr/>
+          <p:nvPr/>
+        </p:nvSpPr>
+        <p:spPr>
+          <a:xfrm>
+            <a:off x="0" y="0"/>
+            <a:ext cx="12191695" cy="73152"/>
+          </a:xfrm>
+          <a:prstGeom prst="rect">
+            <a:avLst/>
+          </a:prstGeom>
+          <a:solidFill>
+            <a:srgbClr val="0066CC"/>
+          </a:solidFill>
+          <a:ln>
+            <a:noFill/>
+          </a:ln>
+        </p:spPr>
+        <p:style>
+          <a:lnRef idx="1">
+            <a:schemeClr val="accent1"/>
+          </a:lnRef>
+          <a:fillRef idx="3">
+            <a:schemeClr val="accent1"/>
+          </a:fillRef>
+          <a:effectRef idx="2">
+            <a:schemeClr val="accent1"/>
+          </a:effectRef>
+          <a:fontRef idx="minor">
+            <a:schemeClr val="lt1"/>
+          </a:fontRef>
+        </p:style>
+        <p:txBody>
+          <a:bodyPr rtlCol="0" anchor="ctr"/>
+          <a:lstStyle/>
+          <a:p>
+            <a:pPr algn="ctr"/>
+          </a:p>
+        </p:txBody>
+      </p:sp>
+      <p:sp>
+        <p:nvSpPr>
+          <p:cNvPr id="3" name="TextBox 2"/>
+          <p:cNvSpPr txBox="1"/>
+          <p:nvPr/>
+        </p:nvSpPr>
+        <p:spPr>
+          <a:xfrm>
+            <a:off x="731520" y="274320"/>
+            <a:ext cx="10058400" cy="731520"/>
+          </a:xfrm>
+          <a:prstGeom prst="rect">
+            <a:avLst/>
+          </a:prstGeom>
+          <a:noFill/>
+        </p:spPr>
+        <p:txBody>
+          <a:bodyPr wrap="none">
+            <a:spAutoFit/>
+          </a:bodyPr>
+          <a:lstStyle/>
+          <a:p>
+            <a:pPr>
+              <a:defRPr sz="2800" b="1">
+                <a:solidFill>
+                  <a:srgbClr val="1E293B"/>
+                </a:solidFill>
+              </a:defRPr>
+            </a:pPr>
+            <a:r>
+              <a:t>Next Steps</a:t>
+            </a:r>
+          </a:p>
+        </p:txBody>
+      </p:sp>
+      <p:sp>
+        <p:nvSpPr>
+          <p:cNvPr id="4" name="TextBox 3"/>
+          <p:cNvSpPr txBox="1"/>
+          <p:nvPr/>
+        </p:nvSpPr>
+        <p:spPr>
+          <a:xfrm>
+            <a:off x="731520" y="1188720"/>
+            <a:ext cx="10515600" cy="5029200"/>
+          </a:xfrm>
+          <a:prstGeom prst="rect">
+            <a:avLst/>
+          </a:prstGeom>
+          <a:noFill/>
+        </p:spPr>
+        <p:txBody>
+          <a:bodyPr wrap="square">
+            <a:spAutoFit/>
+          </a:bodyPr>
+          <a:lstStyle/>
+          <a:p>
+            <a:pPr>
+              <a:spcBef>
+                <a:spcPts val="1200"/>
+              </a:spcBef>
+              <a:defRPr sz="1600" b="1">
+                <a:solidFill>
+                  <a:srgbClr val="1E293B"/>
+                </a:solidFill>
+              </a:defRPr>
+            </a:pPr>
+            <a:r>
+              <a:t>Continued platform depth and integrations</a:t>
+            </a:r>
+          </a:p>
+          <a:p>
+            <a:pPr>
+              <a:spcBef>
+                <a:spcPts val="800"/>
+              </a:spcBef>
+            </a:pPr>
+          </a:p>
+          <a:p>
+            <a:pPr>
+              <a:spcBef>
+                <a:spcPts val="400"/>
+              </a:spcBef>
+              <a:defRPr sz="1400">
+                <a:solidFill>
+                  <a:srgbClr val="64748B"/>
+                </a:solidFill>
+              </a:defRPr>
+            </a:pPr>
+            <a:r>
+              <a:t>Sales Estimate Pipeline: 5-node LangGraph pipeline (analyze &gt; comps &gt; territory &gt; forecast &gt; report)</a:t>
+            </a:r>
+          </a:p>
+          <a:p>
+            <a:pPr>
+              <a:spcBef>
+                <a:spcPts val="400"/>
+              </a:spcBef>
+              <a:defRPr sz="1400">
+                <a:solidFill>
+                  <a:srgbClr val="64748B"/>
+                </a:solidFill>
+              </a:defRPr>
+            </a:pPr>
+            <a:r>
+              <a:t>PDF Script Ingestion: Upload screenplays for automated analysis</a:t>
+            </a:r>
+          </a:p>
+          <a:p>
+            <a:pPr>
+              <a:spcBef>
+                <a:spcPts val="400"/>
+              </a:spcBef>
+              <a:defRPr sz="1400">
+                <a:solidFill>
+                  <a:srgbClr val="64748B"/>
+                </a:solidFill>
+              </a:defRPr>
+            </a:pPr>
+            <a:r>
+              <a:t>Closing Workflow Automation: Drawdown requests, digital signatures</a:t>
+            </a:r>
+          </a:p>
+          <a:p>
+            <a:pPr>
+              <a:spcBef>
+                <a:spcPts val="400"/>
+              </a:spcBef>
+              <a:defRPr sz="1400">
+                <a:solidFill>
+                  <a:srgbClr val="64748B"/>
+                </a:solidFill>
+              </a:defRPr>
+            </a:pPr>
+            <a:r>
+              <a:t>Portfolio Analytics Dashboard: IRR tracking, collection monitoring, variance analysis</a:t>
+            </a:r>
+          </a:p>
+          <a:p>
+            <a:pPr>
+              <a:spcBef>
+                <a:spcPts val="400"/>
+              </a:spcBef>
+              <a:defRPr sz="1400">
+                <a:solidFill>
+                  <a:srgbClr val="64748B"/>
+                </a:solidFill>
+              </a:defRPr>
+            </a:pPr>
+            <a:r>
+              <a:t>Investor Reporting: Automated LP/capital partner reports</a:t>
+            </a:r>
+          </a:p>
+          <a:p>
+            <a:pPr>
+              <a:spcBef>
+                <a:spcPts val="400"/>
+              </a:spcBef>
+              <a:defRPr sz="1400">
+                <a:solidFill>
+                  <a:srgbClr val="64748B"/>
+                </a:solidFill>
+              </a:defRPr>
+            </a:pPr>
+            <a:r>
+              <a:t>Mobile Responsive: Tablet-optimized layout for on-the-go deal review</a:t>
+            </a:r>
+          </a:p>
+        </p:txBody>
+      </p:sp>
+      <p:sp>
+        <p:nvSpPr>
+          <p:cNvPr id="5" name="TextBox 4"/>
+          <p:cNvSpPr txBox="1"/>
+          <p:nvPr/>
+        </p:nvSpPr>
+        <p:spPr>
+          <a:xfrm>
+            <a:off x="731520" y="6400800"/>
+            <a:ext cx="4572000" cy="274320"/>
+          </a:xfrm>
+          <a:prstGeom prst="rect">
+            <a:avLst/>
+          </a:prstGeom>
+          <a:noFill/>
+        </p:spPr>
+        <p:txBody>
+          <a:bodyPr wrap="none">
+            <a:spAutoFit/>
+          </a:bodyPr>
+          <a:lstStyle/>
+          <a:p>
+            <a:pPr>
+              <a:defRPr sz="800">
+                <a:solidFill>
+                  <a:srgbClr val="64748B"/>
+                </a:solidFill>
+              </a:defRPr>
+            </a:pPr>
+            <a:r>
+              <a:t>Ashland Hill Media Finance — Private &amp; Confidential</a:t>
             </a:r>
           </a:p>
         </p:txBody>
@@ -5523,6 +6770,126 @@
 </p:sld>
 </file>
 
+<file path=ppt/slides/slide20.xml><?xml version="1.0" encoding="utf-8"?>
+<p:sld xmlns:a="http://schemas.openxmlformats.org/drawingml/2006/main" xmlns:p="http://schemas.openxmlformats.org/presentationml/2006/main" xmlns:r="http://schemas.openxmlformats.org/officeDocument/2006/relationships">
+  <p:cSld>
+    <p:bg>
+      <p:bgPr>
+        <a:solidFill>
+          <a:srgbClr val="0066CC"/>
+        </a:solidFill>
+        <a:effectLst/>
+      </p:bgPr>
+    </p:bg>
+    <p:spTree>
+      <p:nvGrpSpPr>
+        <p:cNvPr id="1" name=""/>
+        <p:cNvGrpSpPr/>
+        <p:nvPr/>
+      </p:nvGrpSpPr>
+      <p:grpSpPr/>
+      <p:sp>
+        <p:nvSpPr>
+          <p:cNvPr id="2" name="TextBox 1"/>
+          <p:cNvSpPr txBox="1"/>
+          <p:nvPr/>
+        </p:nvSpPr>
+        <p:spPr>
+          <a:xfrm>
+            <a:off x="914400" y="1828800"/>
+            <a:ext cx="10058400" cy="1828800"/>
+          </a:xfrm>
+          <a:prstGeom prst="rect">
+            <a:avLst/>
+          </a:prstGeom>
+          <a:noFill/>
+        </p:spPr>
+        <p:txBody>
+          <a:bodyPr wrap="square">
+            <a:spAutoFit/>
+          </a:bodyPr>
+          <a:lstStyle/>
+          <a:p>
+            <a:pPr>
+              <a:defRPr sz="4400" b="1">
+                <a:solidFill>
+                  <a:srgbClr val="FFFFFF"/>
+                </a:solidFill>
+              </a:defRPr>
+            </a:pPr>
+            <a:r>
+              <a:t>Thank You</a:t>
+            </a:r>
+          </a:p>
+          <a:p>
+            <a:pPr>
+              <a:spcBef>
+                <a:spcPts val="2000"/>
+              </a:spcBef>
+              <a:defRPr sz="2000">
+                <a:solidFill>
+                  <a:srgbClr val="FFFFFF"/>
+                </a:solidFill>
+              </a:defRPr>
+            </a:pPr>
+            <a:r>
+              <a:t>Joe Simpson — Managing Partner</a:t>
+            </a:r>
+            <a:br/>
+            <a:r>
+              <a:t>Simon Williams — Managing Partner</a:t>
+            </a:r>
+            <a:br/>
+            <a:br/>
+            <a:r>
+              <a:t>Ashland Hill Media Finance</a:t>
+            </a:r>
+          </a:p>
+        </p:txBody>
+      </p:sp>
+      <p:sp>
+        <p:nvSpPr>
+          <p:cNvPr id="3" name="TextBox 2"/>
+          <p:cNvSpPr txBox="1"/>
+          <p:nvPr/>
+        </p:nvSpPr>
+        <p:spPr>
+          <a:xfrm>
+            <a:off x="914400" y="5029200"/>
+            <a:ext cx="2743200" cy="457200"/>
+          </a:xfrm>
+          <a:prstGeom prst="rect">
+            <a:avLst/>
+          </a:prstGeom>
+          <a:noFill/>
+        </p:spPr>
+        <p:txBody>
+          <a:bodyPr wrap="none">
+            <a:spAutoFit/>
+          </a:bodyPr>
+          <a:lstStyle/>
+          <a:p>
+            <a:pPr>
+              <a:defRPr sz="1400" b="1">
+                <a:solidFill>
+                  <a:srgbClr val="FFFFFF"/>
+                </a:solidFill>
+              </a:defRPr>
+            </a:pPr>
+            <a:r>
+              <a:t>Ashland Hill Media Finance</a:t>
+            </a:r>
+          </a:p>
+        </p:txBody>
+      </p:sp>
+    </p:spTree>
+  </p:cSld>
+  <p:clrMapOvr>
+    <a:masterClrMapping/>
+  </p:clrMapOvr>
+</p:sld>
+</file>
+
 <file path=ppt/slides/slide3.xml><?xml version="1.0" encoding="utf-8"?>
 <p:sld xmlns:a="http://schemas.openxmlformats.org/drawingml/2006/main" xmlns:p="http://schemas.openxmlformats.org/presentationml/2006/main" xmlns:r="http://schemas.openxmlformats.org/officeDocument/2006/relationships">
   <p:cSld>
@@ -5644,7 +7011,7 @@
               </a:defRPr>
             </a:pPr>
             <a:r>
-              <a:t>The core operating system for Ashland Hill's Media Finance unit</a:t>
+              <a:t>The core operating system — 6 fully operational modules</a:t>
             </a:r>
           </a:p>
           <a:p>
@@ -5696,79 +7063,52 @@
               </a:defRPr>
             </a:pPr>
             <a:r>
-              <a:t>Sales &amp; Collections — Territory-based revenue tracking</a:t>
-            </a:r>
-          </a:p>
-          <a:p>
-            <a:pPr>
-              <a:spcBef>
-                <a:spcPts val="400"/>
-              </a:spcBef>
-              <a:defRPr sz="1400">
-                <a:solidFill>
-                  <a:srgbClr val="64748B"/>
-                </a:solidFill>
-              </a:defRPr>
-            </a:pPr>
-            <a:r>
-              <a:t>Credit Rating — Distributor/producer scoring, payment reliability</a:t>
-            </a:r>
-          </a:p>
-          <a:p>
-            <a:pPr>
-              <a:spcBef>
-                <a:spcPts val="400"/>
-              </a:spcBef>
-              <a:defRPr sz="1400">
-                <a:solidFill>
-                  <a:srgbClr val="64748B"/>
-                </a:solidFill>
-              </a:defRPr>
-            </a:pPr>
-            <a:r>
-              <a:t>Accounting — Multi-account balance tracking, audit trail</a:t>
-            </a:r>
-          </a:p>
-          <a:p>
-            <a:pPr>
-              <a:spcBef>
-                <a:spcPts val="400"/>
-              </a:spcBef>
-              <a:defRPr sz="1400">
-                <a:solidFill>
-                  <a:srgbClr val="64748B"/>
-                </a:solidFill>
-              </a:defRPr>
-            </a:pPr>
-            <a:r>
-              <a:t>Communications — Task assignment, milestone notifications</a:t>
-            </a:r>
-          </a:p>
-          <a:p>
-            <a:pPr>
-              <a:spcBef>
-                <a:spcPts val="400"/>
-              </a:spcBef>
-              <a:defRPr sz="1400">
-                <a:solidFill>
-                  <a:srgbClr val="64748B"/>
-                </a:solidFill>
-              </a:defRPr>
-            </a:pPr>
-          </a:p>
-          <a:p>
-            <a:pPr>
-              <a:spcBef>
-                <a:spcPts val="400"/>
-              </a:spcBef>
-              <a:defRPr sz="1400">
-                <a:solidFill>
-                  <a:srgbClr val="64748B"/>
-                </a:solidFill>
-              </a:defRPr>
-            </a:pPr>
-            <a:r>
-              <a:t>2 deals tracked | $20M total committed | Pipeline &amp; Active statuses</a:t>
+              <a:t>Sales &amp; Collections — Territory contracts, MG tracking, collection payments</a:t>
+            </a:r>
+          </a:p>
+          <a:p>
+            <a:pPr>
+              <a:spcBef>
+                <a:spcPts val="400"/>
+              </a:spcBef>
+              <a:defRPr sz="1400">
+                <a:solidFill>
+                  <a:srgbClr val="64748B"/>
+                </a:solidFill>
+              </a:defRPr>
+            </a:pPr>
+            <a:r>
+              <a:t>Credit Rating — AI-powered counterparty scoring (AAA-CCC tiers)</a:t>
+            </a:r>
+          </a:p>
+          <a:p>
+            <a:pPr>
+              <a:spcBef>
+                <a:spcPts val="400"/>
+              </a:spcBef>
+              <a:defRPr sz="1400">
+                <a:solidFill>
+                  <a:srgbClr val="64748B"/>
+                </a:solidFill>
+              </a:defRPr>
+            </a:pPr>
+            <a:r>
+              <a:t>Accounting — Transaction ledger, disbursements, repayments, net position</a:t>
+            </a:r>
+          </a:p>
+          <a:p>
+            <a:pPr>
+              <a:spcBef>
+                <a:spcPts val="400"/>
+              </a:spcBef>
+              <a:defRPr sz="1400">
+                <a:solidFill>
+                  <a:srgbClr val="64748B"/>
+                </a:solidFill>
+              </a:defRPr>
+            </a:pPr>
+            <a:r>
+              <a:t>Communications — Deal-linked messages, tasks with deadlines, completion tracking</a:t>
             </a:r>
           </a:p>
         </p:txBody>
@@ -6198,7 +7538,7 @@
               </a:defRPr>
             </a:pPr>
             <a:r>
-              <a:t>Sales Estimates Generator</a:t>
+              <a:t>Sales &amp; Collections</a:t>
             </a:r>
           </a:p>
         </p:txBody>
@@ -6236,7 +7576,7 @@
               </a:defRPr>
             </a:pPr>
             <a:r>
-              <a:t>Quantitative valuation intelligence for greenlight and collateral appraisal</a:t>
+              <a:t>Territory-based revenue tracking and collateral monitoring</a:t>
             </a:r>
           </a:p>
           <a:p>
@@ -6258,89 +7598,89 @@
               </a:defRPr>
             </a:pPr>
             <a:r>
-              <a:t>Script ingestion with PDF parsing + metadata extraction</a:t>
-            </a:r>
-          </a:p>
-          <a:p>
-            <a:pPr>
-              <a:spcBef>
-                <a:spcPts val="400"/>
-              </a:spcBef>
-              <a:defRPr sz="1400">
-                <a:solidFill>
-                  <a:srgbClr val="64748B"/>
-                </a:solidFill>
-              </a:defRPr>
-            </a:pPr>
-            <a:r>
-              <a:t>Genre + comp benchmarking via TMDB &amp; OMDB databases</a:t>
-            </a:r>
-          </a:p>
-          <a:p>
-            <a:pPr>
-              <a:spcBef>
-                <a:spcPts val="400"/>
-              </a:spcBef>
-              <a:defRPr sz="1400">
-                <a:solidFill>
-                  <a:srgbClr val="64748B"/>
-                </a:solidFill>
-              </a:defRPr>
-            </a:pPr>
-            <a:r>
-              <a:t>Territory-level MG projections</a:t>
-            </a:r>
-          </a:p>
-          <a:p>
-            <a:pPr>
-              <a:spcBef>
-                <a:spcPts val="400"/>
-              </a:spcBef>
-              <a:defRPr sz="1400">
-                <a:solidFill>
-                  <a:srgbClr val="64748B"/>
-                </a:solidFill>
-              </a:defRPr>
-            </a:pPr>
-            <a:r>
-              <a:t>Box office forecasting (domestic + international)</a:t>
-            </a:r>
-          </a:p>
-          <a:p>
-            <a:pPr>
-              <a:spcBef>
-                <a:spcPts val="400"/>
-              </a:spcBef>
-              <a:defRPr sz="1400">
-                <a:solidFill>
-                  <a:srgbClr val="64748B"/>
-                </a:solidFill>
-              </a:defRPr>
-            </a:pPr>
-            <a:r>
-              <a:t>Confidence score and model reliability rating</a:t>
-            </a:r>
-          </a:p>
-          <a:p>
-            <a:pPr>
-              <a:spcBef>
-                <a:spcPts val="400"/>
-              </a:spcBef>
-              <a:defRPr sz="1400">
-                <a:solidFill>
-                  <a:srgbClr val="64748B"/>
-                </a:solidFill>
-              </a:defRPr>
-            </a:pPr>
-            <a:r>
-              <a:t>Comparable film analysis with budget, revenue, and cast data</a:t>
+              <a:t>Sales contracts linked to deals and distributors</a:t>
+            </a:r>
+          </a:p>
+          <a:p>
+            <a:pPr>
+              <a:spcBef>
+                <a:spcPts val="400"/>
+              </a:spcBef>
+              <a:defRPr sz="1400">
+                <a:solidFill>
+                  <a:srgbClr val="64748B"/>
+                </a:solidFill>
+              </a:defRPr>
+            </a:pPr>
+            <a:r>
+              <a:t>Territory-based MG (Minimum Guarantee) commitments</a:t>
+            </a:r>
+          </a:p>
+          <a:p>
+            <a:pPr>
+              <a:spcBef>
+                <a:spcPts val="400"/>
+              </a:spcBef>
+              <a:defRPr sz="1400">
+                <a:solidFill>
+                  <a:srgbClr val="64748B"/>
+                </a:solidFill>
+              </a:defRPr>
+            </a:pPr>
+            <a:r>
+              <a:t>Collection payment recording with due dates</a:t>
+            </a:r>
+          </a:p>
+          <a:p>
+            <a:pPr>
+              <a:spcBef>
+                <a:spcPts val="400"/>
+              </a:spcBef>
+              <a:defRPr sz="1400">
+                <a:solidFill>
+                  <a:srgbClr val="64748B"/>
+                </a:solidFill>
+              </a:defRPr>
+            </a:pPr>
+            <a:r>
+              <a:t>Status tracking: pending, received, overdue</a:t>
+            </a:r>
+          </a:p>
+          <a:p>
+            <a:pPr>
+              <a:spcBef>
+                <a:spcPts val="400"/>
+              </a:spcBef>
+              <a:defRPr sz="1400">
+                <a:solidFill>
+                  <a:srgbClr val="64748B"/>
+                </a:solidFill>
+              </a:defRPr>
+            </a:pPr>
+            <a:r>
+              <a:t>Variance analysis: projected vs actual collections</a:t>
+            </a:r>
+          </a:p>
+          <a:p>
+            <a:pPr>
+              <a:spcBef>
+                <a:spcPts val="400"/>
+              </a:spcBef>
+              <a:defRPr sz="1400">
+                <a:solidFill>
+                  <a:srgbClr val="64748B"/>
+                </a:solidFill>
+              </a:defRPr>
+            </a:pPr>
+            <a:r>
+              <a:t>Receivable flagging for delayed payments</a:t>
             </a:r>
           </a:p>
         </p:txBody>
       </p:sp>
       <p:pic>
         <p:nvPicPr>
-          <p:cNvPr id="5" name="Picture 4" descr="06_estimates.png"/>
+          <p:cNvPr id="5" name="Picture 4" descr="05_sales.png"/>
           <p:cNvPicPr>
             <a:picLocks noChangeAspect="1"/>
           </p:cNvPicPr>
@@ -6488,7 +7828,7 @@
               </a:defRPr>
             </a:pPr>
             <a:r>
-              <a:t>Production Risk Scoring</a:t>
+              <a:t>Credit Rating</a:t>
             </a:r>
           </a:p>
         </p:txBody>
@@ -6526,7 +7866,7 @@
               </a:defRPr>
             </a:pPr>
             <a:r>
-              <a:t>"Moody's for execution risk"</a:t>
+              <a:t>AI-powered counterparty strength assessment</a:t>
             </a:r>
           </a:p>
           <a:p>
@@ -6548,131 +7888,161 @@
               </a:defRPr>
             </a:pPr>
             <a:r>
-              <a:t>AI evaluates 6 risk dimensions on a 0-100 scale:</a:t>
-            </a:r>
-          </a:p>
-          <a:p>
-            <a:pPr>
-              <a:spcBef>
-                <a:spcPts val="400"/>
-              </a:spcBef>
-              <a:defRPr sz="1400">
-                <a:solidFill>
-                  <a:srgbClr val="64748B"/>
-                </a:solidFill>
-              </a:defRPr>
-            </a:pPr>
-            <a:r>
-              <a:t>  Script Complexity — locations, stunts, VFX density</a:t>
-            </a:r>
-          </a:p>
-          <a:p>
-            <a:pPr>
-              <a:spcBef>
-                <a:spcPts val="400"/>
-              </a:spcBef>
-              <a:defRPr sz="1400">
-                <a:solidFill>
-                  <a:srgbClr val="64748B"/>
-                </a:solidFill>
-              </a:defRPr>
-            </a:pPr>
-            <a:r>
-              <a:t>  Budget Feasibility — budget vs comparable films</a:t>
-            </a:r>
-          </a:p>
-          <a:p>
-            <a:pPr>
-              <a:spcBef>
-                <a:spcPts val="400"/>
-              </a:spcBef>
-              <a:defRPr sz="1400">
-                <a:solidFill>
-                  <a:srgbClr val="64748B"/>
-                </a:solidFill>
-              </a:defRPr>
-            </a:pPr>
-            <a:r>
-              <a:t>  Schedule Risk — shoot days vs scope</a:t>
-            </a:r>
-          </a:p>
-          <a:p>
-            <a:pPr>
-              <a:spcBef>
-                <a:spcPts val="400"/>
-              </a:spcBef>
-              <a:defRPr sz="1400">
-                <a:solidFill>
-                  <a:srgbClr val="64748B"/>
-                </a:solidFill>
-              </a:defRPr>
-            </a:pPr>
-            <a:r>
-              <a:t>  Jurisdictional Risk — labor laws, permits, stability</a:t>
-            </a:r>
-          </a:p>
-          <a:p>
-            <a:pPr>
-              <a:spcBef>
-                <a:spcPts val="400"/>
-              </a:spcBef>
-              <a:defRPr sz="1400">
-                <a:solidFill>
-                  <a:srgbClr val="64748B"/>
-                </a:solidFill>
-              </a:defRPr>
-            </a:pPr>
-            <a:r>
-              <a:t>  Crew/Talent Risk — availability, reliability, concentration</a:t>
-            </a:r>
-          </a:p>
-          <a:p>
-            <a:pPr>
-              <a:spcBef>
-                <a:spcPts val="400"/>
-              </a:spcBef>
-              <a:defRPr sz="1400">
-                <a:solidFill>
-                  <a:srgbClr val="64748B"/>
-                </a:solidFill>
-              </a:defRPr>
-            </a:pPr>
-            <a:r>
-              <a:t>  Completion Risk — on-time, on-budget probability</a:t>
-            </a:r>
-          </a:p>
-          <a:p>
-            <a:pPr>
-              <a:spcBef>
-                <a:spcPts val="400"/>
-              </a:spcBef>
-              <a:defRPr sz="1400">
-                <a:solidFill>
-                  <a:srgbClr val="64748B"/>
-                </a:solidFill>
-              </a:defRPr>
-            </a:pPr>
-          </a:p>
-          <a:p>
-            <a:pPr>
-              <a:spcBef>
-                <a:spcPts val="400"/>
-              </a:spcBef>
-              <a:defRPr sz="1400">
-                <a:solidFill>
-                  <a:srgbClr val="64748B"/>
-                </a:solidFill>
-              </a:defRPr>
-            </a:pPr>
-            <a:r>
-              <a:t>Output: Overall score, risk tier, mitigation recommendations</a:t>
+              <a:t>Select any distributor, producer, or sales agent</a:t>
+            </a:r>
+          </a:p>
+          <a:p>
+            <a:pPr>
+              <a:spcBef>
+                <a:spcPts val="400"/>
+              </a:spcBef>
+              <a:defRPr sz="1400">
+                <a:solidFill>
+                  <a:srgbClr val="64748B"/>
+                </a:solidFill>
+              </a:defRPr>
+            </a:pPr>
+            <a:r>
+              <a:t>AI generates comprehensive credit profile:</a:t>
+            </a:r>
+          </a:p>
+          <a:p>
+            <a:pPr>
+              <a:spcBef>
+                <a:spcPts val="400"/>
+              </a:spcBef>
+              <a:defRPr sz="1400">
+                <a:solidFill>
+                  <a:srgbClr val="64748B"/>
+                </a:solidFill>
+              </a:defRPr>
+            </a:pPr>
+            <a:r>
+              <a:t>  Credit Score (0-100)</a:t>
+            </a:r>
+          </a:p>
+          <a:p>
+            <a:pPr>
+              <a:spcBef>
+                <a:spcPts val="400"/>
+              </a:spcBef>
+              <a:defRPr sz="1400">
+                <a:solidFill>
+                  <a:srgbClr val="64748B"/>
+                </a:solidFill>
+              </a:defRPr>
+            </a:pPr>
+            <a:r>
+              <a:t>  Payment Reliability (0-100)</a:t>
+            </a:r>
+          </a:p>
+          <a:p>
+            <a:pPr>
+              <a:spcBef>
+                <a:spcPts val="400"/>
+              </a:spcBef>
+              <a:defRPr sz="1400">
+                <a:solidFill>
+                  <a:srgbClr val="64748B"/>
+                </a:solidFill>
+              </a:defRPr>
+            </a:pPr>
+            <a:r>
+              <a:t>  Risk Tier (AAA through CCC)</a:t>
+            </a:r>
+          </a:p>
+          <a:p>
+            <a:pPr>
+              <a:spcBef>
+                <a:spcPts val="400"/>
+              </a:spcBef>
+              <a:defRPr sz="1400">
+                <a:solidFill>
+                  <a:srgbClr val="64748B"/>
+                </a:solidFill>
+              </a:defRPr>
+            </a:pPr>
+          </a:p>
+          <a:p>
+            <a:pPr>
+              <a:spcBef>
+                <a:spcPts val="1200"/>
+              </a:spcBef>
+              <a:defRPr sz="1600" b="1">
+                <a:solidFill>
+                  <a:srgbClr val="1E293B"/>
+                </a:solidFill>
+              </a:defRPr>
+            </a:pPr>
+            <a:r>
+              <a:t>Factor Analysis:</a:t>
+            </a:r>
+          </a:p>
+          <a:p>
+            <a:pPr>
+              <a:spcBef>
+                <a:spcPts val="400"/>
+              </a:spcBef>
+              <a:defRPr sz="1400">
+                <a:solidFill>
+                  <a:srgbClr val="64748B"/>
+                </a:solidFill>
+              </a:defRPr>
+            </a:pPr>
+            <a:r>
+              <a:t>  Track Record — historical deal performance</a:t>
+            </a:r>
+          </a:p>
+          <a:p>
+            <a:pPr>
+              <a:spcBef>
+                <a:spcPts val="400"/>
+              </a:spcBef>
+              <a:defRPr sz="1400">
+                <a:solidFill>
+                  <a:srgbClr val="64748B"/>
+                </a:solidFill>
+              </a:defRPr>
+            </a:pPr>
+            <a:r>
+              <a:t>  Financial Stability — company financials</a:t>
+            </a:r>
+          </a:p>
+          <a:p>
+            <a:pPr>
+              <a:spcBef>
+                <a:spcPts val="400"/>
+              </a:spcBef>
+              <a:defRPr sz="1400">
+                <a:solidFill>
+                  <a:srgbClr val="64748B"/>
+                </a:solidFill>
+              </a:defRPr>
+            </a:pPr>
+            <a:r>
+              <a:t>  Market Position — competitive standing</a:t>
+            </a:r>
+          </a:p>
+          <a:p>
+            <a:pPr>
+              <a:spcBef>
+                <a:spcPts val="400"/>
+              </a:spcBef>
+              <a:defRPr sz="1400">
+                <a:solidFill>
+                  <a:srgbClr val="64748B"/>
+                </a:solidFill>
+              </a:defRPr>
+            </a:pPr>
+            <a:r>
+              <a:t>  Payment History — on-time payment patterns</a:t>
             </a:r>
           </a:p>
         </p:txBody>
       </p:sp>
       <p:pic>
         <p:nvPicPr>
-          <p:cNvPr id="5" name="Picture 4" descr="08_risk_form.png"/>
+          <p:cNvPr id="5" name="Picture 4" descr="17_credit.png"/>
           <p:cNvPicPr>
             <a:picLocks noChangeAspect="1"/>
           </p:cNvPicPr>
@@ -6687,7 +8057,7 @@
         <p:spPr>
           <a:xfrm>
             <a:off x="6217920" y="1188720"/>
-            <a:ext cx="5303520" cy="3729038"/>
+            <a:ext cx="5303520" cy="5162989"/>
           </a:xfrm>
           <a:prstGeom prst="rect">
             <a:avLst/>
@@ -6820,7 +8190,7 @@
               </a:defRPr>
             </a:pPr>
             <a:r>
-              <a:t>Smart Budgeting Tool</a:t>
+              <a:t>Accounting</a:t>
             </a:r>
           </a:p>
         </p:txBody>
@@ -6858,7 +8228,7 @@
               </a:defRPr>
             </a:pPr>
             <a:r>
-              <a:t>Generative budgeting logic + live cost intelligence</a:t>
+              <a:t>Transaction-level financial integrity</a:t>
             </a:r>
           </a:p>
           <a:p>
@@ -6880,146 +8250,89 @@
               </a:defRPr>
             </a:pPr>
             <a:r>
-              <a:t>AI generates 3 scenarios: Low / Mid / High</a:t>
-            </a:r>
-          </a:p>
-          <a:p>
-            <a:pPr>
-              <a:spcBef>
-                <a:spcPts val="400"/>
-              </a:spcBef>
-              <a:defRPr sz="1400">
-                <a:solidFill>
-                  <a:srgbClr val="64748B"/>
-                </a:solidFill>
-              </a:defRPr>
-            </a:pPr>
-            <a:r>
-              <a:t>8-12 detailed line items per scenario</a:t>
-            </a:r>
-          </a:p>
-          <a:p>
-            <a:pPr>
-              <a:spcBef>
-                <a:spcPts val="400"/>
-              </a:spcBef>
-              <a:defRPr sz="1400">
-                <a:solidFill>
-                  <a:srgbClr val="64748B"/>
-                </a:solidFill>
-              </a:defRPr>
-            </a:pPr>
-          </a:p>
-          <a:p>
-            <a:pPr>
-              <a:spcBef>
-                <a:spcPts val="1200"/>
-              </a:spcBef>
-              <a:defRPr sz="1600" b="1">
-                <a:solidFill>
-                  <a:srgbClr val="1E293B"/>
-                </a:solidFill>
-              </a:defRPr>
-            </a:pPr>
-            <a:r>
-              <a:t>Budget Categories:</a:t>
-            </a:r>
-          </a:p>
-          <a:p>
-            <a:pPr>
-              <a:spcBef>
-                <a:spcPts val="400"/>
-              </a:spcBef>
-              <a:defRPr sz="1400">
-                <a:solidFill>
-                  <a:srgbClr val="64748B"/>
-                </a:solidFill>
-              </a:defRPr>
-            </a:pPr>
-            <a:r>
-              <a:t>Above-the-Line (talent, director, producer fees)</a:t>
-            </a:r>
-          </a:p>
-          <a:p>
-            <a:pPr>
-              <a:spcBef>
-                <a:spcPts val="400"/>
-              </a:spcBef>
-              <a:defRPr sz="1400">
-                <a:solidFill>
-                  <a:srgbClr val="64748B"/>
-                </a:solidFill>
-              </a:defRPr>
-            </a:pPr>
-            <a:r>
-              <a:t>Below-the-Line Production (crew, equipment, locations)</a:t>
-            </a:r>
-          </a:p>
-          <a:p>
-            <a:pPr>
-              <a:spcBef>
-                <a:spcPts val="400"/>
-              </a:spcBef>
-              <a:defRPr sz="1400">
-                <a:solidFill>
-                  <a:srgbClr val="64748B"/>
-                </a:solidFill>
-              </a:defRPr>
-            </a:pPr>
-            <a:r>
-              <a:t>Below-the-Line Post (editing, VFX, sound, music)</a:t>
-            </a:r>
-          </a:p>
-          <a:p>
-            <a:pPr>
-              <a:spcBef>
-                <a:spcPts val="400"/>
-              </a:spcBef>
-              <a:defRPr sz="1400">
-                <a:solidFill>
-                  <a:srgbClr val="64748B"/>
-                </a:solidFill>
-              </a:defRPr>
-            </a:pPr>
-            <a:r>
-              <a:t>Insurance &amp; Legal</a:t>
-            </a:r>
-          </a:p>
-          <a:p>
-            <a:pPr>
-              <a:spcBef>
-                <a:spcPts val="400"/>
-              </a:spcBef>
-              <a:defRPr sz="1400">
-                <a:solidFill>
-                  <a:srgbClr val="64748B"/>
-                </a:solidFill>
-              </a:defRPr>
-            </a:pPr>
-            <a:r>
-              <a:t>Financing Costs</a:t>
-            </a:r>
-          </a:p>
-          <a:p>
-            <a:pPr>
-              <a:spcBef>
-                <a:spcPts val="400"/>
-              </a:spcBef>
-              <a:defRPr sz="1400">
-                <a:solidFill>
-                  <a:srgbClr val="64748B"/>
-                </a:solidFill>
-              </a:defRPr>
-            </a:pPr>
-            <a:r>
-              <a:t>Contingency (typically 10%)</a:t>
+              <a:t>Full transaction ledger across all deals</a:t>
+            </a:r>
+          </a:p>
+          <a:p>
+            <a:pPr>
+              <a:spcBef>
+                <a:spcPts val="400"/>
+              </a:spcBef>
+              <a:defRPr sz="1400">
+                <a:solidFill>
+                  <a:srgbClr val="64748B"/>
+                </a:solidFill>
+              </a:defRPr>
+            </a:pPr>
+            <a:r>
+              <a:t>Transaction types: Disbursement, Repayment, Fee, Interest, Adjustment</a:t>
+            </a:r>
+          </a:p>
+          <a:p>
+            <a:pPr>
+              <a:spcBef>
+                <a:spcPts val="400"/>
+              </a:spcBef>
+              <a:defRPr sz="1400">
+                <a:solidFill>
+                  <a:srgbClr val="64748B"/>
+                </a:solidFill>
+              </a:defRPr>
+            </a:pPr>
+            <a:r>
+              <a:t>Multi-currency support (USD, EUR, GBP, CAD, AUD, JPY, CNY)</a:t>
+            </a:r>
+          </a:p>
+          <a:p>
+            <a:pPr>
+              <a:spcBef>
+                <a:spcPts val="400"/>
+              </a:spcBef>
+              <a:defRPr sz="1400">
+                <a:solidFill>
+                  <a:srgbClr val="64748B"/>
+                </a:solidFill>
+              </a:defRPr>
+            </a:pPr>
+            <a:r>
+              <a:t>Net position tracking (repaid + fees - disbursed)</a:t>
+            </a:r>
+          </a:p>
+          <a:p>
+            <a:pPr>
+              <a:spcBef>
+                <a:spcPts val="400"/>
+              </a:spcBef>
+              <a:defRPr sz="1400">
+                <a:solidFill>
+                  <a:srgbClr val="64748B"/>
+                </a:solidFill>
+              </a:defRPr>
+            </a:pPr>
+            <a:r>
+              <a:t>Counterparty linking for audit trail</a:t>
+            </a:r>
+          </a:p>
+          <a:p>
+            <a:pPr>
+              <a:spcBef>
+                <a:spcPts val="400"/>
+              </a:spcBef>
+              <a:defRPr sz="1400">
+                <a:solidFill>
+                  <a:srgbClr val="64748B"/>
+                </a:solidFill>
+              </a:defRPr>
+            </a:pPr>
+            <a:r>
+              <a:t>Reference notes per transaction</a:t>
             </a:r>
           </a:p>
         </p:txBody>
       </p:sp>
       <p:pic>
         <p:nvPicPr>
-          <p:cNvPr id="5" name="Picture 4" descr="09_budget.png"/>
+          <p:cNvPr id="5" name="Picture 4" descr="18_accounting.png"/>
           <p:cNvPicPr>
             <a:picLocks noChangeAspect="1"/>
           </p:cNvPicPr>
@@ -7034,7 +8347,7 @@
         <p:spPr>
           <a:xfrm>
             <a:off x="6217920" y="1188720"/>
-            <a:ext cx="5303520" cy="3729038"/>
+            <a:ext cx="5303520" cy="5162989"/>
           </a:xfrm>
           <a:prstGeom prst="rect">
             <a:avLst/>
@@ -7167,7 +8480,7 @@
               </a:defRPr>
             </a:pPr>
             <a:r>
-              <a:t>Automated Production Scheduling</a:t>
+              <a:t>Communications</a:t>
             </a:r>
           </a:p>
         </p:txBody>
@@ -7205,7 +8518,7 @@
               </a:defRPr>
             </a:pPr>
             <a:r>
-              <a:t>Predictive production efficiency software</a:t>
+              <a:t>Execution control layer for deal teams</a:t>
             </a:r>
           </a:p>
           <a:p>
@@ -7227,104 +8540,89 @@
               </a:defRPr>
             </a:pPr>
             <a:r>
-              <a:t>AI generates day-by-day shooting schedules</a:t>
-            </a:r>
-          </a:p>
-          <a:p>
-            <a:pPr>
-              <a:spcBef>
-                <a:spcPts val="400"/>
-              </a:spcBef>
-              <a:defRPr sz="1400">
-                <a:solidFill>
-                  <a:srgbClr val="64748B"/>
-                </a:solidFill>
-              </a:defRPr>
-            </a:pPr>
-            <a:r>
-              <a:t>Location clustering optimization (minimize company moves)</a:t>
-            </a:r>
-          </a:p>
-          <a:p>
-            <a:pPr>
-              <a:spcBef>
-                <a:spcPts val="400"/>
-              </a:spcBef>
-              <a:defRPr sz="1400">
-                <a:solidFill>
-                  <a:srgbClr val="64748B"/>
-                </a:solidFill>
-              </a:defRPr>
-            </a:pPr>
-            <a:r>
-              <a:t>Day/night scene grouping</a:t>
-            </a:r>
-          </a:p>
-          <a:p>
-            <a:pPr>
-              <a:spcBef>
-                <a:spcPts val="400"/>
-              </a:spcBef>
-              <a:defRPr sz="1400">
-                <a:solidFill>
-                  <a:srgbClr val="64748B"/>
-                </a:solidFill>
-              </a:defRPr>
-            </a:pPr>
-            <a:r>
-              <a:t>Actor availability and labor law compliance</a:t>
-            </a:r>
-          </a:p>
-          <a:p>
-            <a:pPr>
-              <a:spcBef>
-                <a:spcPts val="400"/>
-              </a:spcBef>
-              <a:defRPr sz="1400">
-                <a:solidFill>
-                  <a:srgbClr val="64748B"/>
-                </a:solidFill>
-              </a:defRPr>
-            </a:pPr>
-            <a:r>
-              <a:t>Bottleneck prediction</a:t>
-            </a:r>
-          </a:p>
-          <a:p>
-            <a:pPr>
-              <a:spcBef>
-                <a:spcPts val="400"/>
-              </a:spcBef>
-              <a:defRPr sz="1400">
-                <a:solidFill>
-                  <a:srgbClr val="64748B"/>
-                </a:solidFill>
-              </a:defRPr>
-            </a:pPr>
-            <a:r>
-              <a:t>Scenario comparison (schedule A vs B)</a:t>
-            </a:r>
-          </a:p>
-          <a:p>
-            <a:pPr>
-              <a:spcBef>
-                <a:spcPts val="400"/>
-              </a:spcBef>
-              <a:defRPr sz="1400">
-                <a:solidFill>
-                  <a:srgbClr val="64748B"/>
-                </a:solidFill>
-              </a:defRPr>
-            </a:pPr>
-            <a:r>
-              <a:t>Integration with budgeting tool</a:t>
+              <a:t>Deal-linked messages, tasks, and notifications</a:t>
+            </a:r>
+          </a:p>
+          <a:p>
+            <a:pPr>
+              <a:spcBef>
+                <a:spcPts val="400"/>
+              </a:spcBef>
+              <a:defRPr sz="1400">
+                <a:solidFill>
+                  <a:srgbClr val="64748B"/>
+                </a:solidFill>
+              </a:defRPr>
+            </a:pPr>
+            <a:r>
+              <a:t>Task assignment with due dates and deadlines</a:t>
+            </a:r>
+          </a:p>
+          <a:p>
+            <a:pPr>
+              <a:spcBef>
+                <a:spcPts val="400"/>
+              </a:spcBef>
+              <a:defRPr sz="1400">
+                <a:solidFill>
+                  <a:srgbClr val="64748B"/>
+                </a:solidFill>
+              </a:defRPr>
+            </a:pPr>
+            <a:r>
+              <a:t>Interactive checkboxes to mark task completion</a:t>
+            </a:r>
+          </a:p>
+          <a:p>
+            <a:pPr>
+              <a:spcBef>
+                <a:spcPts val="400"/>
+              </a:spcBef>
+              <a:defRPr sz="1400">
+                <a:solidFill>
+                  <a:srgbClr val="64748B"/>
+                </a:solidFill>
+              </a:defRPr>
+            </a:pPr>
+            <a:r>
+              <a:t>Overdue task flagging for missed deadlines</a:t>
+            </a:r>
+          </a:p>
+          <a:p>
+            <a:pPr>
+              <a:spcBef>
+                <a:spcPts val="400"/>
+              </a:spcBef>
+              <a:defRPr sz="1400">
+                <a:solidFill>
+                  <a:srgbClr val="64748B"/>
+                </a:solidFill>
+              </a:defRPr>
+            </a:pPr>
+            <a:r>
+              <a:t>Status dashboard: open tasks, completed, overdue</a:t>
+            </a:r>
+          </a:p>
+          <a:p>
+            <a:pPr>
+              <a:spcBef>
+                <a:spcPts val="400"/>
+              </a:spcBef>
+              <a:defRPr sz="1400">
+                <a:solidFill>
+                  <a:srgbClr val="64748B"/>
+                </a:solidFill>
+              </a:defRPr>
+            </a:pPr>
+            <a:r>
+              <a:t>Full message history per deal</a:t>
             </a:r>
           </a:p>
         </p:txBody>
       </p:sp>
       <p:pic>
         <p:nvPicPr>
-          <p:cNvPr id="5" name="Picture 4" descr="10_schedule.png"/>
+          <p:cNvPr id="5" name="Picture 4" descr="19_comms.png"/>
           <p:cNvPicPr>
             <a:picLocks noChangeAspect="1"/>
           </p:cNvPicPr>
@@ -7339,7 +8637,7 @@
         <p:spPr>
           <a:xfrm>
             <a:off x="6217920" y="1188720"/>
-            <a:ext cx="5303520" cy="3729038"/>
+            <a:ext cx="5303520" cy="5162989"/>
           </a:xfrm>
           <a:prstGeom prst="rect">
             <a:avLst/>
@@ -7472,7 +8770,7 @@
               </a:defRPr>
             </a:pPr>
             <a:r>
-              <a:t>Soft Funding Discovery Engine</a:t>
+              <a:t>Sales Estimates Generator</a:t>
             </a:r>
           </a:p>
         </p:txBody>
@@ -7510,7 +8808,7 @@
               </a:defRPr>
             </a:pPr>
             <a:r>
-              <a:t>"Kayak for film incentives"</a:t>
+              <a:t>Quantitative valuation intelligence for greenlight and collateral appraisal</a:t>
             </a:r>
           </a:p>
           <a:p>
@@ -7532,173 +8830,89 @@
               </a:defRPr>
             </a:pPr>
             <a:r>
-              <a:t>Database of 16+ global incentive programs</a:t>
-            </a:r>
-          </a:p>
-          <a:p>
-            <a:pPr>
-              <a:spcBef>
-                <a:spcPts val="400"/>
-              </a:spcBef>
-              <a:defRPr sz="1400">
-                <a:solidFill>
-                  <a:srgbClr val="64748B"/>
-                </a:solidFill>
-              </a:defRPr>
-            </a:pPr>
-            <a:r>
-              <a:t>11 countries covered</a:t>
-            </a:r>
-          </a:p>
-          <a:p>
-            <a:pPr>
-              <a:spcBef>
-                <a:spcPts val="400"/>
-              </a:spcBef>
-              <a:defRPr sz="1400">
-                <a:solidFill>
-                  <a:srgbClr val="64748B"/>
-                </a:solidFill>
-              </a:defRPr>
-            </a:pPr>
-            <a:r>
-              <a:t>Average rebate: 27.8%</a:t>
-            </a:r>
-          </a:p>
-          <a:p>
-            <a:pPr>
-              <a:spcBef>
-                <a:spcPts val="400"/>
-              </a:spcBef>
-              <a:defRPr sz="1400">
-                <a:solidFill>
-                  <a:srgbClr val="64748B"/>
-                </a:solidFill>
-              </a:defRPr>
-            </a:pPr>
-          </a:p>
-          <a:p>
-            <a:pPr>
-              <a:spcBef>
-                <a:spcPts val="1200"/>
-              </a:spcBef>
-              <a:defRPr sz="1600" b="1">
-                <a:solidFill>
-                  <a:srgbClr val="1E293B"/>
-                </a:solidFill>
-              </a:defRPr>
-            </a:pPr>
-            <a:r>
-              <a:t>Top Programs:</a:t>
-            </a:r>
-          </a:p>
-          <a:p>
-            <a:pPr>
-              <a:spcBef>
-                <a:spcPts val="400"/>
-              </a:spcBef>
-              <a:defRPr sz="1400">
-                <a:solidFill>
-                  <a:srgbClr val="64748B"/>
-                </a:solidFill>
-              </a:defRPr>
-            </a:pPr>
-            <a:r>
-              <a:t>  Colombia Cash Rebate — 40%</a:t>
-            </a:r>
-          </a:p>
-          <a:p>
-            <a:pPr>
-              <a:spcBef>
-                <a:spcPts val="400"/>
-              </a:spcBef>
-              <a:defRPr sz="1400">
-                <a:solidFill>
-                  <a:srgbClr val="64748B"/>
-                </a:solidFill>
-              </a:defRPr>
-            </a:pPr>
-            <a:r>
-              <a:t>  Ireland Section 481 — 32%</a:t>
-            </a:r>
-          </a:p>
-          <a:p>
-            <a:pPr>
-              <a:spcBef>
-                <a:spcPts val="400"/>
-              </a:spcBef>
-              <a:defRPr sz="1400">
-                <a:solidFill>
-                  <a:srgbClr val="64748B"/>
-                </a:solidFill>
-              </a:defRPr>
-            </a:pPr>
-            <a:r>
-              <a:t>  Georgia Tax Credit — 30%</a:t>
-            </a:r>
-          </a:p>
-          <a:p>
-            <a:pPr>
-              <a:spcBef>
-                <a:spcPts val="400"/>
-              </a:spcBef>
-              <a:defRPr sz="1400">
-                <a:solidFill>
-                  <a:srgbClr val="64748B"/>
-                </a:solidFill>
-              </a:defRPr>
-            </a:pPr>
-            <a:r>
-              <a:t>  Hungary Cash Rebate — 30%</a:t>
-            </a:r>
-          </a:p>
-          <a:p>
-            <a:pPr>
-              <a:spcBef>
-                <a:spcPts val="400"/>
-              </a:spcBef>
-              <a:defRPr sz="1400">
-                <a:solidFill>
-                  <a:srgbClr val="64748B"/>
-                </a:solidFill>
-              </a:defRPr>
-            </a:pPr>
-            <a:r>
-              <a:t>  Australia PDV Offset — 30%</a:t>
-            </a:r>
-          </a:p>
-          <a:p>
-            <a:pPr>
-              <a:spcBef>
-                <a:spcPts val="400"/>
-              </a:spcBef>
-              <a:defRPr sz="1400">
-                <a:solidFill>
-                  <a:srgbClr val="64748B"/>
-                </a:solidFill>
-              </a:defRPr>
-            </a:pPr>
-          </a:p>
-          <a:p>
-            <a:pPr>
-              <a:spcBef>
-                <a:spcPts val="400"/>
-              </a:spcBef>
-              <a:defRPr sz="1400">
-                <a:solidFill>
-                  <a:srgbClr val="64748B"/>
-                </a:solidFill>
-              </a:defRPr>
-            </a:pPr>
-            <a:r>
-              <a:t>Built-in rebate calculator and eligibility filters</a:t>
+              <a:t>Script ingestion with PDF parsing + metadata extraction</a:t>
+            </a:r>
+          </a:p>
+          <a:p>
+            <a:pPr>
+              <a:spcBef>
+                <a:spcPts val="400"/>
+              </a:spcBef>
+              <a:defRPr sz="1400">
+                <a:solidFill>
+                  <a:srgbClr val="64748B"/>
+                </a:solidFill>
+              </a:defRPr>
+            </a:pPr>
+            <a:r>
+              <a:t>Genre + comp benchmarking via TMDB &amp; OMDB databases</a:t>
+            </a:r>
+          </a:p>
+          <a:p>
+            <a:pPr>
+              <a:spcBef>
+                <a:spcPts val="400"/>
+              </a:spcBef>
+              <a:defRPr sz="1400">
+                <a:solidFill>
+                  <a:srgbClr val="64748B"/>
+                </a:solidFill>
+              </a:defRPr>
+            </a:pPr>
+            <a:r>
+              <a:t>Territory-level MG projections</a:t>
+            </a:r>
+          </a:p>
+          <a:p>
+            <a:pPr>
+              <a:spcBef>
+                <a:spcPts val="400"/>
+              </a:spcBef>
+              <a:defRPr sz="1400">
+                <a:solidFill>
+                  <a:srgbClr val="64748B"/>
+                </a:solidFill>
+              </a:defRPr>
+            </a:pPr>
+            <a:r>
+              <a:t>Box office forecasting (domestic + international)</a:t>
+            </a:r>
+          </a:p>
+          <a:p>
+            <a:pPr>
+              <a:spcBef>
+                <a:spcPts val="400"/>
+              </a:spcBef>
+              <a:defRPr sz="1400">
+                <a:solidFill>
+                  <a:srgbClr val="64748B"/>
+                </a:solidFill>
+              </a:defRPr>
+            </a:pPr>
+            <a:r>
+              <a:t>Confidence score and model reliability rating</a:t>
+            </a:r>
+          </a:p>
+          <a:p>
+            <a:pPr>
+              <a:spcBef>
+                <a:spcPts val="400"/>
+              </a:spcBef>
+              <a:defRPr sz="1400">
+                <a:solidFill>
+                  <a:srgbClr val="64748B"/>
+                </a:solidFill>
+              </a:defRPr>
+            </a:pPr>
+            <a:r>
+              <a:t>Comparable film analysis with budget, revenue, and cast data</a:t>
             </a:r>
           </a:p>
         </p:txBody>
       </p:sp>
       <p:pic>
         <p:nvPicPr>
-          <p:cNvPr id="5" name="Picture 4" descr="04_funding.png"/>
+          <p:cNvPr id="5" name="Picture 4" descr="06_estimates.png"/>
           <p:cNvPicPr>
             <a:picLocks noChangeAspect="1"/>
           </p:cNvPicPr>
@@ -7713,7 +8927,7 @@
         <p:spPr>
           <a:xfrm>
             <a:off x="6217920" y="1188720"/>
-            <a:ext cx="5303520" cy="5162989"/>
+            <a:ext cx="5303520" cy="3729038"/>
           </a:xfrm>
           <a:prstGeom prst="rect">
             <a:avLst/>

</xml_diff>